<commit_message>
Apply Humanizer v4.0.0: eradicate em-dashes, eliminate decorative icons, and polish technical PE tone
</commit_message>
<xml_diff>
--- a/Bao_Cao_Dieu_Chinh_IrisEXP_VN.pptx
+++ b/Bao_Cao_Dieu_Chinh_IrisEXP_VN.pptx
@@ -3337,7 +3337,7 @@
               </a:defRPr>
             </a:pPr>
             <a:r>
-              <a:t>Tăng gấp đôi năng suất — Đảm bảo sản xuất IrisEXP trên Line Iris2024 hiện tại</a:t>
+              <a:t>Mục tiêu tăng gấp đôi năng suất, đáp ứng sản lượng trên chuyền Iris2024 hiện tại</a:t>
             </a:r>
           </a:p>
         </p:txBody>
@@ -3475,7 +3475,7 @@
             </a:r>
             <a:br/>
             <a:r>
-              <a:t>&amp; Bài toán nhịp Takt 97s IrisEXP</a:t>
+              <a:t>và bài toán nhịp Takt 97s IrisEXP</a:t>
             </a:r>
           </a:p>
         </p:txBody>
@@ -3609,11 +3609,11 @@
               </a:defRPr>
             </a:pPr>
             <a:r>
-              <a:t>Tăng gấp đôi năng suất (≥30,4 máy)</a:t>
+              <a:t>Năng suất một người tăng gấp đôi (≥30,4 máy)</a:t>
             </a:r>
             <a:br/>
             <a:r>
-              <a:t>Giảm 50% thời gian &amp; số tờ in</a:t>
+              <a:t>Cắt giảm 50% thời gian và số tờ in</a:t>
             </a:r>
           </a:p>
         </p:txBody>
@@ -3747,11 +3747,11 @@
               </a:defRPr>
             </a:pPr>
             <a:r>
-              <a:t>JP định hướng — VN &amp; CN chủ động</a:t>
+              <a:t>Nhật Bản định hướng, nhà máy chủ động</a:t>
             </a:r>
             <a:br/>
             <a:r>
-              <a:t>Phối hợp định kỳ cùng giải quyết</a:t>
+              <a:t>Đồng bộ định kỳ ba cứ điểm</a:t>
             </a:r>
           </a:p>
         </p:txBody>
@@ -3889,7 +3889,7 @@
             </a:r>
             <a:br/>
             <a:r>
-              <a:t>&amp; Dự toán đầu tư (Tham khảo 38 ĐA)</a:t>
+              <a:t>và dự toán đầu tư (Tham khảo 38 ĐA)</a:t>
             </a:r>
           </a:p>
         </p:txBody>
@@ -4185,7 +4185,7 @@
               </a:defRPr>
             </a:pPr>
             <a:r>
-              <a:t>■ Đề nghị phê duyệt Phương án A (Triển khai ngay Đề án No.22: 101.690.000 VNĐ / 3.911,15 USD) hoặc Phương án B (Trọn gói 3 đề án trong file: 855.690.000 VNĐ / 32.911,15 USD).</a:t>
+              <a:t>Đề xuất phê duyệt Phương án 1 đầu tư JIG đo an toàn điện No.22 (101,69 triệu VNĐ / 3.911,15 USD), hoặc Phương án 2 đầu tư trọn gói cả 3 đề án (855,69 triệu VNĐ / 32.911,15 USD).</a:t>
             </a:r>
           </a:p>
         </p:txBody>
@@ -4915,7 +4915,7 @@
                         </a:defRPr>
                       </a:pPr>
                       <a:r>
-                        <a:t>TỔNG ĐỀ ÁN NO.22 (PHƯƠNG ÁN A)</a:t>
+                        <a:t>TỔNG ĐỀ ÁN NO.22 (PHƯƠNG ÁN 1)</a:t>
                       </a:r>
                       <a:br/>
                       <a:r>
@@ -5138,7 +5138,7 @@
               <a:spcAft>
                 <a:spcPts val="300"/>
               </a:spcAft>
-              <a:defRPr sz="1200" b="1">
+              <a:defRPr sz="1200">
                 <a:solidFill>
                   <a:srgbClr val="1E242B"/>
                 </a:solidFill>
@@ -5146,7 +5146,7 @@
               </a:defRPr>
             </a:pPr>
             <a:r>
-              <a:t>■ PHƯƠNG ÁN A (Khuyến nghị lựa chọn — Triển khai ngay No.22):</a:t>
+              <a:t>Phương án 1 (Ưu tiên lựa chọn): Triển khai ngay JIG đo an toàn điện No.22.</a:t>
             </a:r>
           </a:p>
           <a:p>
@@ -5162,7 +5162,7 @@
               </a:defRPr>
             </a:pPr>
             <a:r>
-              <a:t>   • Duyệt trước Đề án No.22: 101.690.000 VNĐ (3.911,15 USD).</a:t>
+              <a:t>- Kinh phí: 101.690.000 VNĐ (3.911,15 USD / làm tròn: 4.000 USD).</a:t>
             </a:r>
           </a:p>
           <a:p>
@@ -5178,7 +5178,7 @@
               </a:defRPr>
             </a:pPr>
             <a:r>
-              <a:t>   • Hiệu quả: Giảm 30s/máy, tiết kiệm 29,6 triệu VNĐ/năm, hoàn vốn ~3,4 năm.</a:t>
+              <a:t>- Hiệu quả: Giảm 30s/máy, tiết kiệm 29,6 triệu VNĐ/năm, hoàn vốn trong 3,4 năm.</a:t>
             </a:r>
           </a:p>
           <a:p>
@@ -5194,7 +5194,7 @@
               </a:defRPr>
             </a:pPr>
             <a:r>
-              <a:t>   • Thay Robot No.23 &amp; No.24 bằng khay DP và đọc log Host PC (tiết kiệm 754 triệu VNĐ tiền Robot).</a:t>
+              <a:t>- Tối ưu vốn: Hủy 2 robot No.23 và No.24 để tiết kiệm 754 triệu VNĐ. Hạng mục Camera No.27 (-177s) và khay DP No.25 sẽ trình duyệt ở Đợt 2.</a:t>
             </a:r>
           </a:p>
           <a:p>
@@ -5210,55 +5210,7 @@
               </a:defRPr>
             </a:pPr>
             <a:r>
-              <a:t>   • Các mục Camera No.27 (-177s) và DP No.25 hoàn tất báo giá trình duyệt Đợt 2.</a:t>
-            </a:r>
-          </a:p>
-          <a:p>
-            <a:pPr>
-              <a:spcAft>
-                <a:spcPts val="300"/>
-              </a:spcAft>
-              <a:defRPr sz="1200" b="1">
-                <a:solidFill>
-                  <a:srgbClr val="1E242B"/>
-                </a:solidFill>
-                <a:latin typeface="Times New Roman"/>
-              </a:defRPr>
-            </a:pPr>
-            <a:r>
-              <a:t>■ PHƯƠNG ÁN B (Duyệt trọn gói 3 đề án có giá trong file VN提案.xlsx):</a:t>
-            </a:r>
-          </a:p>
-          <a:p>
-            <a:pPr>
-              <a:spcAft>
-                <a:spcPts val="300"/>
-              </a:spcAft>
-              <a:defRPr sz="1200">
-                <a:solidFill>
-                  <a:srgbClr val="1E242B"/>
-                </a:solidFill>
-                <a:latin typeface="Times New Roman"/>
-              </a:defRPr>
-            </a:pPr>
-            <a:r>
-              <a:t>   • No.22 (101,69tr) + No.23 Robot ISU (650tr) + No.24 Robot USB/U201 (104tr).</a:t>
-            </a:r>
-          </a:p>
-          <a:p>
-            <a:pPr>
-              <a:spcAft>
-                <a:spcPts val="300"/>
-              </a:spcAft>
-              <a:defRPr sz="1200">
-                <a:solidFill>
-                  <a:srgbClr val="1E242B"/>
-                </a:solidFill>
-                <a:latin typeface="Times New Roman"/>
-              </a:defRPr>
-            </a:pPr>
-            <a:r>
-              <a:t>   • Tổng kinh phí: 855.690.000 VNĐ (32.911,15 USD / làm tròn: 33.000 USD).</a:t>
+              <a:t>Phương án 2: Duyệt trọn gói cả 3 đề án theo dự toán ban đầu (855,69 triệu VNĐ / 32.911,15 USD).</a:t>
             </a:r>
           </a:p>
         </p:txBody>
@@ -5395,7 +5347,7 @@
               </a:defRPr>
             </a:pPr>
             <a:r>
-              <a:t>1. Lựa chọn Phương án ngân sách: Chọn Phương án A hay B trước ngày 15/11/2026.</a:t>
+              <a:t>1. Lựa chọn phương án ngân sách: Xin ý kiến chọn Phương án 1 hay Phương án 2 trước ngày 15/11/2026.</a:t>
             </a:r>
           </a:p>
           <a:p>
@@ -5411,7 +5363,7 @@
               </a:defRPr>
             </a:pPr>
             <a:r>
-              <a:t>2. Chuyển nguyên công lắp 6 tấm vỏ: Chỉ đạo làm việc với bộ phận Lắp ráp và PE Nhật để chuyển bước lắp 6 vỏ ngoài về cuối chuyền Lắp ráp (No.33, chi phí 0 đồng).</a:t>
+              <a:t>2. Chuyển công đoạn lắp 6 tấm vỏ: Chỉ đạo phối hợp với Lắp ráp và PE Nhật để chuyển bước lắp 6 vỏ ngoài về cuối chuyền Lắp ráp (No.33, chi phí 0 đồng).</a:t>
             </a:r>
           </a:p>
           <a:p>
@@ -5427,7 +5379,7 @@
               </a:defRPr>
             </a:pPr>
             <a:r>
-              <a:t>3. Chốt lịch DR công đoạn: Hỗ trợ thúc đẩy Thiết kế JP phản hồi 6 kiến nghị sửa mạch/FW của VN trong tháng 11/2026 để kịp chạy thử PMT1 (T12/2026).</a:t>
+              <a:t>3. Chốt lịch họp DR công đoạn: Thúc đẩy Thiết kế Nhật phản hồi 6 kiến nghị sửa mạch và phần mềm của Việt Nam trong tháng 11/2026 để kịp chạy thử PMT1 vào tháng 12/2026.</a:t>
             </a:r>
           </a:p>
         </p:txBody>
@@ -5668,7 +5620,7 @@
               </a:defRPr>
             </a:pPr>
             <a:r>
-              <a:t>■ Năng suất lao động tăng gấp đôi (15,19 -&gt; ≥30,38 máy/người/ngày), giảm 50% thời gian thao tác, giảm 50% số người xuống 8~9 người, đảm bảo sản xuất trên Line hiện tại.</a:t>
+              <a:t>Sau cải tiến, năng suất lao động tăng gấp đôi từ 15,19 lên trên 30,38 máy/người/ngày; nhân sự rút gọn còn 8 đến 9 người, đáp ứng yêu cầu sản xuất ngay trên chuyền Iris2024.</a:t>
             </a:r>
           </a:p>
         </p:txBody>
@@ -6517,7 +6469,7 @@
                         </a:defRPr>
                       </a:pPr>
                       <a:r>
-                        <a:t>Lập 28 -&gt; 37 đề án; khảo sát nhà cung cấp và lập dự toán đầu tư VN提案.</a:t>
+                        <a:t>Lập 28 đến 37 đề án; khảo sát nhà cung cấp và lập dự toán đầu tư VN提案.</a:t>
                       </a:r>
                     </a:p>
                   </a:txBody>
@@ -6681,7 +6633,7 @@
                         </a:defRPr>
                       </a:pPr>
                       <a:r>
-                        <a:t>Chốt DR công đoạn; chế tạo JIG No.22, Camera No.27; chạy thử 4 cụm trạm A-1~A-4.</a:t>
+                        <a:t>Chốt DR công đoạn; chế tạo JIG No.22, Camera No.27; chạy thử 4 cụm trạm A-1 đến A-4.</a:t>
                       </a:r>
                     </a:p>
                   </a:txBody>
@@ -7042,7 +6994,7 @@
               </a:defRPr>
             </a:pPr>
             <a:r>
-              <a:t>■ Bảng đối chiếu tổng thể số lượng đề án, thời gian giảm, nhân lực và kinh phí của cả 3 cứ điểm (JP - CN - VN) xếp ở phần tham khảo cuối bài.</a:t>
+              <a:t>Đối chiếu tổng thể số lượng đề án, thời gian cắt giảm, nhân lực và kinh phí giữa ba cứ điểm Nhật Bản, Trung Quốc và Việt Nam.</a:t>
             </a:r>
           </a:p>
         </p:txBody>
@@ -8152,7 +8104,7 @@
               </a:defRPr>
             </a:pPr>
             <a:r>
-              <a:t>■ Danh mục đề án của Nhật Bản và Trung Quốc trong tài liệu tổng hợp chung (IrisEXP改善提案まとめ.xlsx) và trạng thái triển khai ngang.</a:t>
+              <a:t>Danh mục 7 đề án của Nhật Bản và 11 đề án của Trung Quốc theo tài liệu tổng hợp chung, cùng kế hoạch triển khai ngang tại KDTVN.</a:t>
             </a:r>
           </a:p>
         </p:txBody>
@@ -9631,7 +9583,7 @@
               </a:defRPr>
             </a:pPr>
             <a:r>
-              <a:t>■ Tổng hợp 6 vấn đề kỹ thuật và chi phí phát sinh từ 17 cuộc họp liên kết (保証工程連携会) và DR4 cùng đối sách kỹ thuật đã thống nhất.</a:t>
+              <a:t>Tổng hợp 6 vấn đề kỹ thuật và phát sinh chi phí từ 17 cuộc họp liên kết ba cứ điểm, kèm phương án đối sách đã thống nhất sau DR4.</a:t>
             </a:r>
           </a:p>
         </p:txBody>
@@ -10586,7 +10538,7 @@
               </a:defRPr>
             </a:pPr>
             <a:r>
-              <a:t>■ Danh mục toàn bộ 38 đề án (Nhật Bản: No.1~7 | Trung Quốc: No.8~17, No.38 | Việt Nam: No.18~37) trích xuất nguyên bản từ tài liệu tổng hợp chung.</a:t>
+              <a:t>Bảng tra cứu đầy đủ 38 đề án cải tiến của ba cứ điểm được trích xuất từ tài liệu tổng hợp chung IrisEXP改善提案まとめ.xlsx.</a:t>
             </a:r>
           </a:p>
         </p:txBody>
@@ -13039,7 +12991,7 @@
               </a:defRPr>
             </a:pPr>
             <a:r>
-              <a:t>■ Hiện trạng 16 người làm 243 máy/ngày (15,19 máy/người). Sang IrisEXP (Takt 97s, 300 máy/ngày), giữ quy trình cũ cần 18 người — Line hiện tại không thể đáp ứng.</a:t>
+              <a:t>Chuyền Iris2024 hiện cần 16 người để đạt 243 máy/ngày (15,19 máy/người). Khi sang IrisEXP theo nhịp Takt 97s (300 máy/ngày), quy trình cũ cần 18 người, vượt quá năng lực mặt bằng hiện có.</a:t>
             </a:r>
           </a:p>
         </p:txBody>
@@ -13277,7 +13229,7 @@
                         </a:defRPr>
                       </a:pPr>
                       <a:r>
-                        <a:t>Thao tác thủ công dài,</a:t>
+                        <a:t>Thao tác dài,</a:t>
                       </a:r>
                       <a:br/>
                       <a:r>
@@ -13497,11 +13449,11 @@
                         </a:defRPr>
                       </a:pPr>
                       <a:r>
-                        <a:t>Tăng sản lượng +23,5%</a:t>
+                        <a:t>Yêu cầu tăng sản lượng</a:t>
                       </a:r>
                       <a:br/>
                       <a:r>
-                        <a:t>(+57 máy/ngày)</a:t>
+                        <a:t>+57 máy/ngày (+23,5%)</a:t>
                       </a:r>
                     </a:p>
                   </a:txBody>
@@ -14100,7 +14052,7 @@
               <a:spcAft>
                 <a:spcPts val="300"/>
               </a:spcAft>
-              <a:defRPr sz="1200" b="1">
+              <a:defRPr sz="1200">
                 <a:solidFill>
                   <a:srgbClr val="1E242B"/>
                 </a:solidFill>
@@ -14108,7 +14060,7 @@
               </a:defRPr>
             </a:pPr>
             <a:r>
-              <a:t>⚠ 1. Hụt sản lượng: Năng lực hiện tại (15,19 máy/người/ngày) với 16 người chỉ làm được 243 máy/ngày, hụt 57 máy/ngày so với yêu cầu Takt 97s (300 máy/ngày).</a:t>
+              <a:t>1. Thiếu hụt 57 máy/ngày: Năng lực hiện tại chỉ đạt 243 máy/ngày (15,19 máy/người), không đạt mục tiêu 300 máy/ngày theo nhịp Takt 97s.</a:t>
             </a:r>
           </a:p>
           <a:p>
@@ -14116,7 +14068,7 @@
               <a:spcAft>
                 <a:spcPts val="300"/>
               </a:spcAft>
-              <a:defRPr sz="1200" b="1">
+              <a:defRPr sz="1200">
                 <a:solidFill>
                   <a:srgbClr val="1E242B"/>
                 </a:solidFill>
@@ -14124,7 +14076,7 @@
               </a:defRPr>
             </a:pPr>
             <a:r>
-              <a:t>⚠ 2. Quá tải diện tích Line: Nếu giữ cách cũ cần 18 người thao tác, vượt quá diện tích và số bàn kiểm tra trên Line Iris2024 (chỉ đủ chỗ cho 16 người).</a:t>
+              <a:t>2. Quá tải mặt bằng chuyền: Quy trình cũ cần 18 người thao tác, trong khi diện tích và số bàn thử hiện tại chỉ bố trí tối đa 16 người.</a:t>
             </a:r>
           </a:p>
           <a:p>
@@ -14132,7 +14084,7 @@
               <a:spcAft>
                 <a:spcPts val="300"/>
               </a:spcAft>
-              <a:defRPr sz="1200" b="1">
+              <a:defRPr sz="1200">
                 <a:solidFill>
                   <a:srgbClr val="1E242B"/>
                 </a:solidFill>
@@ -14140,7 +14092,7 @@
               </a:defRPr>
             </a:pPr>
             <a:r>
-              <a:t>⚠ 3. Nghẽn tại cụm Hình ảnh: In 17 tờ Print + 2 tờ Copy và đo nồng độ thủ công mất 192s, 9 người thao tác không thể theo kịp nhịp Takt 97s.</a:t>
+              <a:t>3. Điểm nghẽn cụm Hình ảnh: Công đoạn in 17 tờ Print, 2 tờ Copy và đo nồng độ thủ công mất 192s, 9 người không thể đáp ứng nhịp Takt 97s.</a:t>
             </a:r>
           </a:p>
           <a:p>
@@ -14148,7 +14100,7 @@
               <a:spcAft>
                 <a:spcPts val="300"/>
               </a:spcAft>
-              <a:defRPr sz="1200" b="1">
+              <a:defRPr sz="1200">
                 <a:solidFill>
                   <a:srgbClr val="1E242B"/>
                 </a:solidFill>
@@ -14156,7 +14108,7 @@
               </a:defRPr>
             </a:pPr>
             <a:r>
-              <a:t>■ 4. Giải pháp bắt buộc: Tăng gấp đôi năng suất (lên ≥30,38 máy/người/ngày), giảm nhân sự xuống 8~9 người để sản xuất ngay trên Line hiện tại.</a:t>
+              <a:t>4. Yêu cầu cải tiến: Nâng năng suất lên ≥30,38 máy/người/ngày và rút gọn nhân sự còn 8 đến 9 người để sản xuất ngay trên chuyền hiện tại.</a:t>
             </a:r>
           </a:p>
         </p:txBody>
@@ -14397,7 +14349,7 @@
               </a:defRPr>
             </a:pPr>
             <a:r>
-              <a:t>■ Line Iris2024 gồm 11 trạm A1~A11 (16 người thao tác). Diện tích mặt bằng đã tối ưu sát giới hạn xưởng (57m x 2,7m), không thể mở rộng hay tăng người.</a:t>
+              <a:t>Chuyền Điều chỉnh Iris2024 bố trí 11 trạm A1 đến A11 với 16 người thao tác trên diện tích 57m x 2,7m, không còn khả năng cơi nới diện tích hoặc bổ sung người đứng chuyền.</a:t>
             </a:r>
           </a:p>
         </p:txBody>
@@ -14656,7 +14608,7 @@
               </a:defRPr>
             </a:pPr>
             <a:r>
-              <a:t>• Bố trí: Dọc chuyền đẩy tay đầu Line (7 người thao tác).</a:t>
+              <a:t>Vị trí: Bố trí dọc chuyền đẩy tay đầu Line với 7 người thao tác.</a:t>
             </a:r>
           </a:p>
           <a:p>
@@ -14672,7 +14624,7 @@
               </a:defRPr>
             </a:pPr>
             <a:r>
-              <a:t>• Thao tác: Nạp soft, gá mực, TLBĐ, U155, Option, lắp 6 vỏ ngoài, đo chịu áp.</a:t>
+              <a:t>Thao tác: Nạp phần mềm, gá mực, đo TLBĐ, U155, lắp Option, lắp 6 vỏ ngoài, đo an toàn điện.</a:t>
             </a:r>
           </a:p>
           <a:p>
@@ -14688,7 +14640,7 @@
               </a:defRPr>
             </a:pPr>
             <a:r>
-              <a:t>• Bất cập: Cắm/rút cáp 11 lần, tháo lắp đồ gá nhiều lần; mất 48s~90s lắp vỏ ngoài.</a:t>
+              <a:t>Điểm nghẽn: Thao tác cắm rút cáp 11 lần, tháo lắp đồ gá lặp lại nhiều lần, mất 48s đến 90s lắp vỏ ngoài.</a:t>
             </a:r>
           </a:p>
         </p:txBody>
@@ -14825,7 +14777,7 @@
               </a:defRPr>
             </a:pPr>
             <a:r>
-              <a:t>• Bố trí: Trên băng tải tự động trước và trong khu vực Aging.</a:t>
+              <a:t>Vị trí: Bố trí trên băng tải tự động trước và trong khu vực Aging.</a:t>
             </a:r>
           </a:p>
           <a:p>
@@ -14841,7 +14793,7 @@
               </a:defRPr>
             </a:pPr>
             <a:r>
-              <a:t>• Thao tác: Nhận diện giấy, chỉnh ISU U411, Scan SITC-2, U201, Aging U950 (285s).</a:t>
+              <a:t>Thao tác: Nhận diện giấy, chỉnh ISU U411, quét SITC-2, U201, chạy Aging U950 (285s).</a:t>
             </a:r>
           </a:p>
           <a:p>
@@ -14857,7 +14809,7 @@
               </a:defRPr>
             </a:pPr>
             <a:r>
-              <a:t>• Bất cập: Mở nắp kính đặt 3 bản thảo thủ công (110s); chu kỳ Aging 285s gây nghẽn.</a:t>
+              <a:t>Điểm nghẽn: Mở nắp kính đặt 3 bản thảo thủ công mất 110s; chu kỳ chờ Aging 285s gây ùn ứ máy.</a:t>
             </a:r>
           </a:p>
         </p:txBody>
@@ -14994,7 +14946,7 @@
               </a:defRPr>
             </a:pPr>
             <a:r>
-              <a:t>• Bố trí: Cell 2 bên (1 người 3 Cell), buồng âm A9, 5 Cell xuất hàng A11.</a:t>
+              <a:t>Vị trí: Cell hai bên (1 người phụ trách 3 Cell), buồng âm A9 và 5 Cell xuất hàng A11.</a:t>
             </a:r>
           </a:p>
           <a:p>
@@ -15010,7 +14962,7 @@
               </a:defRPr>
             </a:pPr>
             <a:r>
-              <a:t>• Thao tác: In 17 tờ Print + 2 tờ Copy, đo nồng độ tay mất 192s, thiết lập xuất hàng.</a:t>
+              <a:t>Thao tác: In 17 tờ Print, 2 tờ Copy, đo nồng độ màu thủ công mất 192s, thiết lập xuất hàng.</a:t>
             </a:r>
           </a:p>
           <a:p>
@@ -15026,7 +14978,7 @@
               </a:defRPr>
             </a:pPr>
             <a:r>
-              <a:t>• Bất cập: Quá tải cụm in/đo; Cell A11 đã giảm từ 6-&gt;5 Cell, không còn chỗ tăng người.</a:t>
+              <a:t>Điểm nghẽn: Quá tải cụm in và đo ảnh; Cell A11 đã giảm từ 6 xuống 5 Cell, không còn chỗ tăng thêm người.</a:t>
             </a:r>
           </a:p>
         </p:txBody>
@@ -15267,7 +15219,7 @@
               </a:defRPr>
             </a:pPr>
             <a:r>
-              <a:t>■ Tăng gấp đôi năng suất (1 người làm ≥30,38 máy/ngày), giảm 50% thời gian thao tác &amp; nhân sự để đảm bảo sản xuất 300 máy/ngày (Takt 97s) ngay trên Line Iris2024 hiện tại.</a:t>
+              <a:t>Mục tiêu phát triển của bác Goto: Tăng gấp đôi năng suất (≥30,38 máy/người/ngày), cắt giảm 50% thời gian thao tác và nhân sự, giữ nguyên diện tích chuyền hiện có.</a:t>
             </a:r>
           </a:p>
         </p:txBody>
@@ -15396,7 +15348,7 @@
               <a:spcAft>
                 <a:spcPts val="300"/>
               </a:spcAft>
-              <a:defRPr sz="1200" b="1">
+              <a:defRPr sz="1200">
                 <a:solidFill>
                   <a:srgbClr val="1E242B"/>
                 </a:solidFill>
@@ -15404,7 +15356,7 @@
               </a:defRPr>
             </a:pPr>
             <a:r>
-              <a:t>■ Định hướng thiết kế:</a:t>
+              <a:t>Định hướng thiết kế: Thiết lập bảo chứng theo từng module, chuyển thao tác kiểm tra về thượng nguồn.</a:t>
             </a:r>
           </a:p>
           <a:p>
@@ -15420,23 +15372,7 @@
               </a:defRPr>
             </a:pPr>
             <a:r>
-              <a:t>• Thiết lập bảo chứng theo từng MODULE, chuyển thao tác kiểm tra về thượng nguồn.</a:t>
-            </a:r>
-          </a:p>
-          <a:p>
-            <a:pPr>
-              <a:spcAft>
-                <a:spcPts val="300"/>
-              </a:spcAft>
-              <a:defRPr sz="1200" b="1">
-                <a:solidFill>
-                  <a:srgbClr val="1E242B"/>
-                </a:solidFill>
-                <a:latin typeface="Times New Roman"/>
-              </a:defRPr>
-            </a:pPr>
-            <a:r>
-              <a:t>■ Mục tiêu cụ thể:</a:t>
+              <a:t>Mục tiêu cụ thể: Cắt giảm từ một nửa đến toàn bộ công sức tại ít nhất 3 hạng mục:</a:t>
             </a:r>
           </a:p>
           <a:p>
@@ -15452,7 +15388,7 @@
               </a:defRPr>
             </a:pPr>
             <a:r>
-              <a:t>• Hủy bỏ hoặc giảm 1/2 công sức ≥ 3 hạng mục:</a:t>
+              <a:t>- Bỏ cài đặt ngưỡng mực thải WTB U155.</a:t>
             </a:r>
           </a:p>
           <a:p>
@@ -15468,7 +15404,7 @@
               </a:defRPr>
             </a:pPr>
             <a:r>
-              <a:t>  - Bỏ cài đặt ngưỡng mực thải WTB U155.</a:t>
+              <a:t>- Bỏ đo độ lệch Belt trung chuyển.</a:t>
             </a:r>
           </a:p>
           <a:p>
@@ -15484,23 +15420,7 @@
               </a:defRPr>
             </a:pPr>
             <a:r>
-              <a:t>  - Bỏ đo độ lệch Belt trung chuyển.</a:t>
-            </a:r>
-          </a:p>
-          <a:p>
-            <a:pPr>
-              <a:spcAft>
-                <a:spcPts val="300"/>
-              </a:spcAft>
-              <a:defRPr sz="1200">
-                <a:solidFill>
-                  <a:srgbClr val="1E242B"/>
-                </a:solidFill>
-                <a:latin typeface="Times New Roman"/>
-              </a:defRPr>
-            </a:pPr>
-            <a:r>
-              <a:t>  - Tự động hóa kiểm tra an toàn điện (No.22).</a:t>
+              <a:t>- Tự động hóa kiểm tra an toàn điện (Đề án No.22).</a:t>
             </a:r>
           </a:p>
         </p:txBody>
@@ -15629,7 +15549,7 @@
               <a:spcAft>
                 <a:spcPts val="300"/>
               </a:spcAft>
-              <a:defRPr sz="1200" b="1">
+              <a:defRPr sz="1200">
                 <a:solidFill>
                   <a:srgbClr val="1E242B"/>
                 </a:solidFill>
@@ -15637,7 +15557,7 @@
               </a:defRPr>
             </a:pPr>
             <a:r>
-              <a:t>■ Cắt giảm thời gian tiêu chuẩn:</a:t>
+              <a:t>Thời gian tiêu chuẩn: Giảm 50% thời gian thao tác (1.083s xuống ≤ 541s/máy; gross 2.350s xuống ≤ 1.175s).</a:t>
             </a:r>
           </a:p>
           <a:p>
@@ -15653,23 +15573,7 @@
               </a:defRPr>
             </a:pPr>
             <a:r>
-              <a:t>• Giảm 50% thời gian thao tác tiêu chuẩn (1.083s -&gt; ≤ 541s/máy; gross: 2.350s -&gt; ≤ 1.175s).</a:t>
-            </a:r>
-          </a:p>
-          <a:p>
-            <a:pPr>
-              <a:spcAft>
-                <a:spcPts val="300"/>
-              </a:spcAft>
-              <a:defRPr sz="1200" b="1">
-                <a:solidFill>
-                  <a:srgbClr val="1E242B"/>
-                </a:solidFill>
-                <a:latin typeface="Times New Roman"/>
-              </a:defRPr>
-            </a:pPr>
-            <a:r>
-              <a:t>■ Giảm một nửa số tờ in kiểm tra:</a:t>
+              <a:t>Số tờ in kiểm tra: Cắt giảm một nửa số lượng bản in:</a:t>
             </a:r>
           </a:p>
           <a:p>
@@ -15685,7 +15589,7 @@
               </a:defRPr>
             </a:pPr>
             <a:r>
-              <a:t>• Bản in Print: Cắt giảm từ 17 tờ → 9 tờ.</a:t>
+              <a:t>- Bản in Print: Cắt giảm từ 17 tờ xuống 9 tờ.</a:t>
             </a:r>
           </a:p>
           <a:p>
@@ -15701,7 +15605,7 @@
               </a:defRPr>
             </a:pPr>
             <a:r>
-              <a:t>• Bản in Copy: Cắt giảm từ 2 tờ → 1 tờ.</a:t>
+              <a:t>- Bản in Copy: Cắt giảm từ 2 tờ xuống 1 tờ.</a:t>
             </a:r>
           </a:p>
           <a:p>
@@ -15717,7 +15621,7 @@
               </a:defRPr>
             </a:pPr>
             <a:r>
-              <a:t>• Ứng dụng AI phân tích video thao tác.</a:t>
+              <a:t>Phần mềm: Ứng dụng AI phân tích video thao tác tìm lãng phí.</a:t>
             </a:r>
           </a:p>
         </p:txBody>
@@ -15846,7 +15750,7 @@
               <a:spcAft>
                 <a:spcPts val="300"/>
               </a:spcAft>
-              <a:defRPr sz="1200" b="1">
+              <a:defRPr sz="1200">
                 <a:solidFill>
                   <a:srgbClr val="1E242B"/>
                 </a:solidFill>
@@ -15854,7 +15758,7 @@
               </a:defRPr>
             </a:pPr>
             <a:r>
-              <a:t>■ Tự động hóa công đoạn:</a:t>
+              <a:t>Tự động hóa công đoạn: Triển khai 7 cụm thao tác lớn gồm JIG an toàn điện, Camera đo màu, khay nạp DP và phần mềm mạng Spica.</a:t>
             </a:r>
           </a:p>
           <a:p>
@@ -15870,55 +15774,7 @@
               </a:defRPr>
             </a:pPr>
             <a:r>
-              <a:t>• Tự động hóa 7 cụm thao tác lớn (JIG, Camera, khay nạp DP, phần mềm mạng Spica).</a:t>
-            </a:r>
-          </a:p>
-          <a:p>
-            <a:pPr>
-              <a:spcAft>
-                <a:spcPts val="300"/>
-              </a:spcAft>
-              <a:defRPr sz="1200" b="1">
-                <a:solidFill>
-                  <a:srgbClr val="1E242B"/>
-                </a:solidFill>
-                <a:latin typeface="Times New Roman"/>
-              </a:defRPr>
-            </a:pPr>
-            <a:r>
-              <a:t>■ Mục tiêu cốt lõi tại KDTVN:</a:t>
-            </a:r>
-          </a:p>
-          <a:p>
-            <a:pPr>
-              <a:spcAft>
-                <a:spcPts val="300"/>
-              </a:spcAft>
-              <a:defRPr sz="1200">
-                <a:solidFill>
-                  <a:srgbClr val="1E242B"/>
-                </a:solidFill>
-                <a:latin typeface="Times New Roman"/>
-              </a:defRPr>
-            </a:pPr>
-            <a:r>
-              <a:t>• Năng suất 1 người tăng x2: 15,19 → ≥ 30,38 máy/ngày.</a:t>
-            </a:r>
-          </a:p>
-          <a:p>
-            <a:pPr>
-              <a:spcAft>
-                <a:spcPts val="300"/>
-              </a:spcAft>
-              <a:defRPr sz="1200">
-                <a:solidFill>
-                  <a:srgbClr val="1E242B"/>
-                </a:solidFill>
-                <a:latin typeface="Times New Roman"/>
-              </a:defRPr>
-            </a:pPr>
-            <a:r>
-              <a:t>• Giảm 50% người thao tác: từ 16~18 người xuống 8~9 người, đảm bảo sản xuất trên Line hiện tại.</a:t>
+              <a:t>Mục tiêu tại KDTVN: Tăng năng suất một người lên gấp đôi (15,19 lên ≥ 30,38 máy/ngày); giảm 50% nhân sự (16 đến 18 người xuống 8 đến 9 người).</a:t>
             </a:r>
           </a:p>
         </p:txBody>
@@ -16035,7 +15891,7 @@
                         </a:defRPr>
                       </a:pPr>
                       <a:r>
-                        <a:t>Tăng x2 năng suất</a:t>
+                        <a:t>Tăng gấp đôi năng suất</a:t>
                       </a:r>
                       <a:br/>
                       <a:r>
@@ -16043,7 +15899,7 @@
                       </a:r>
                       <a:br/>
                       <a:r>
-                        <a:t>Giảm 50% số người (còn 8~9)</a:t>
+                        <a:t>Giảm 50% nhân sự (còn 8 đến 9)</a:t>
                       </a:r>
                     </a:p>
                   </a:txBody>
@@ -16067,11 +15923,11 @@
                         </a:defRPr>
                       </a:pPr>
                       <a:r>
-                        <a:t>1. Thiết kế lại Line &amp; Bảo chứng Module:</a:t>
+                        <a:t>1. Bố trí lại chuyền và bảo chứng module:</a:t>
                       </a:r>
                       <a:br/>
                       <a:r>
-                        <a:t>Chuyển việc kiểm tra về Unit/Sub-Assy hoặc xóa bỏ thao tác thừa</a:t>
+                        <a:t>Chuyển kiểm tra về cụm lắp ráp phụ hoặc xóa bỏ thao tác thừa</a:t>
                       </a:r>
                     </a:p>
                   </a:txBody>
@@ -16095,11 +15951,11 @@
                         </a:defRPr>
                       </a:pPr>
                       <a:r>
-                        <a:t>• Áp dụng hệ Host PC ~ Spica Mini PC, gom 8 trạm thành 4 cụm A-1 ~ A-4.</a:t>
+                        <a:t>Áp dụng hệ Host PC và Spica Mini PC, gộp 8 trạm thành 4 cụm A-1 đến A-4.</a:t>
                       </a:r>
                       <a:br/>
                       <a:r>
-                        <a:t>• Bỏ cài đặt WTB U155; bỏ bấm tay U201; chuyển 6 tấm vỏ về Lắp ráp.</a:t>
+                        <a:t>Bỏ cài đặt WTB U155; bỏ bấm tay U201; chuyển 6 tấm vỏ về Lắp ráp.</a:t>
                       </a:r>
                     </a:p>
                   </a:txBody>
@@ -16129,7 +15985,7 @@
                       </a:r>
                       <a:br/>
                       <a:r>
-                        <a:t>(1.083s -&gt; ≤ 541s)</a:t>
+                        <a:t>(1.083s xuống ≤ 541s)</a:t>
                       </a:r>
                       <a:br/>
                       <a:r>
@@ -16157,11 +16013,11 @@
                         </a:defRPr>
                       </a:pPr>
                       <a:r>
-                        <a:t>2. Giảm số bản in test &amp; Bỏ bước lặp:</a:t>
+                        <a:t>2. Giảm số bản in test và bỏ bước lặp:</a:t>
                       </a:r>
                       <a:br/>
                       <a:r>
-                        <a:t>Tích hợp các tờ in kiểm tra và gộp câu lệnh phần mềm</a:t>
+                        <a:t>Tích hợp các tờ in kiểm tra và gộp lệnh phần mềm</a:t>
                       </a:r>
                     </a:p>
                   </a:txBody>
@@ -16185,11 +16041,11 @@
                         </a:defRPr>
                       </a:pPr>
                       <a:r>
-                        <a:t>• Hủy in RCG trước U950; gộp RCG Ledger &amp; LSU Skew vào Color Regist.</a:t>
+                        <a:t>Hủy in RCG trước U950; gộp RCG Ledger và LSU Skew vào Color Regist.</a:t>
                       </a:r>
                       <a:br/>
                       <a:r>
-                        <a:t>• Gộp Calibration U410 thành 1 lệnh; gộp Mono vào Check Black; gộp Copy DC-1 + Gray.</a:t>
+                        <a:t>Gộp Calibration U410 thành 1 lệnh; gộp Mono vào Check Black; gộp Copy DC-1 + Gray.</a:t>
                       </a:r>
                     </a:p>
                   </a:txBody>
@@ -16219,7 +16075,7 @@
                       </a:r>
                       <a:br/>
                       <a:r>
-                        <a:t>Cpk công đoạn khi MP ≥ 1,33</a:t>
+                        <a:t>Cpk công đoạn khi sản xuất MP ≥ 1,33</a:t>
                       </a:r>
                     </a:p>
                   </a:txBody>
@@ -16243,11 +16099,11 @@
                         </a:defRPr>
                       </a:pPr>
                       <a:r>
-                        <a:t>3. Tự động hóa bằng Đồ gá, Camera, DP:</a:t>
+                        <a:t>3. Tự động hóa bằng đồ gá, camera, khay DP:</a:t>
                       </a:r>
                       <a:br/>
                       <a:r>
-                        <a:t>Thu thập dữ liệu liên kết chất lượng Module với ảnh</a:t>
+                        <a:t>Thu thập dữ liệu liên kết chất lượng module với ảnh chụp</a:t>
                       </a:r>
                     </a:p>
                   </a:txBody>
@@ -16271,11 +16127,11 @@
                         </a:defRPr>
                       </a:pPr>
                       <a:r>
-                        <a:t>• Gá kết nối nhanh Option (No.21); JIG tự động đo an toàn điện No.22 (101,69 tr VNĐ).</a:t>
+                        <a:t>Gá kết nối nhanh Option (No.21); JIG tự động đo an toàn điện No.22 (101,69 triệu VNĐ).</a:t>
                       </a:r>
                       <a:br/>
                       <a:r>
-                        <a:t>• Quét liên tục bằng khay DP (No.25); Camera HIKROBOT đo nồng độ &amp; lề (No.27).</a:t>
+                        <a:t>Quét liên tục bằng khay DP (No.25); Camera HIKROBOT đo nồng độ và lề bản in (No.27).</a:t>
                       </a:r>
                     </a:p>
                   </a:txBody>
@@ -16526,7 +16382,7 @@
               </a:defRPr>
             </a:pPr>
             <a:r>
-              <a:t>■ Nhật Bản định hướng &amp; điều phối kỹ thuật — Việt Nam &amp; Trung Quốc chủ động tại hiện trường — Ba cứ điểm phối hợp giải quyết trên tài liệu chung.</a:t>
+              <a:t>Nhật Bản định hướng thiết kế và điều phối kỹ thuật; Việt Nam và Trung Quốc chủ động xử lý tại xưởng; ba cứ điểm đồng bộ trên tài liệu chung.</a:t>
             </a:r>
           </a:p>
         </p:txBody>
@@ -16581,7 +16437,7 @@
               </a:defRPr>
             </a:pPr>
             <a:r>
-              <a:t>SLOGAN: "ĐỊNH HƯỚNG TỔNG THỂ — CHỦ ĐỘNG HIỆN TRƯỜNG — ĐỒNG BỘ BA CỨ ĐIỂM"</a:t>
+              <a:t>PHƯƠNG CHÂM PHỐI HỢP: NHẬT BẢN ĐỊNH HƯỚNG, NHÀ MÁY CHỦ ĐỘNG, BA CỨ ĐIỂM ĐỒNG BỘ</a:t>
             </a:r>
           </a:p>
           <a:p>
@@ -16594,7 +16450,7 @@
               </a:defRPr>
             </a:pPr>
             <a:r>
-              <a:t>JP định hướng &amp; điều phối  |  VN &amp; CN chủ động giải pháp tại xưởng  |  Họp định kỳ hàng tuần cùng chia sẻ &amp; giải quyết</a:t>
+              <a:t>Nhật Bản định hướng kỹ thuật  |  Việt Nam và Trung Quốc chủ động tại xưởng  |  Họp định kỳ hàng tuần cùng tháo gỡ vướng mắc</a:t>
             </a:r>
           </a:p>
         </p:txBody>
@@ -16731,7 +16587,7 @@
               </a:defRPr>
             </a:pPr>
             <a:r>
-              <a:t>• Định hướng thiết kế tổng thể: Xây dựng cấu trúc chuẩn công đoạn Bảo chứng thân máy và lộ trình kỹ thuật.</a:t>
+              <a:t>Định hướng thiết kế tổng thể: Xây dựng cấu trúc chuẩn công đoạn Bảo chứng thân máy và lộ trình kỹ thuật.</a:t>
             </a:r>
           </a:p>
           <a:p>
@@ -16747,7 +16603,7 @@
               </a:defRPr>
             </a:pPr>
             <a:r>
-              <a:t>• Review &amp; phê duyệt: Đánh giá tính khả thi và phê duyệt thiết kế/QA cho các đề án từ các nhà máy.</a:t>
+              <a:t>Đánh giá và phê duyệt: Thẩm định tính khả thi và phê duyệt tiêu chuẩn kỹ thuật QA cho các đề án từ nhà máy.</a:t>
             </a:r>
           </a:p>
           <a:p>
@@ -16763,7 +16619,7 @@
               </a:defRPr>
             </a:pPr>
             <a:r>
-              <a:t>• Điều phối kỹ thuật: Phối hợp giữa Thiết kế, Phần mềm, QA và PE xử lý vướng mắc.</a:t>
+              <a:t>Điều phối kỹ thuật: Kết nối các bộ phận Thiết kế, Phần mềm, QA và Kỹ thuật sản xuất xử lý vướng mắc.</a:t>
             </a:r>
           </a:p>
         </p:txBody>
@@ -16900,7 +16756,7 @@
               </a:defRPr>
             </a:pPr>
             <a:r>
-              <a:t>• Chủ động tìm vấn đề: Bấm giờ, quay video phân tích thao tác và bóc tách điểm nghẽn thực tế trên chuyền.</a:t>
+              <a:t>Chủ động phát hiện vấn đề: Bấm giờ thao tác, phân tích video và bóc tách điểm nghẽn thực tế trên chuyền.</a:t>
             </a:r>
           </a:p>
           <a:p>
@@ -16916,7 +16772,7 @@
               </a:defRPr>
             </a:pPr>
             <a:r>
-              <a:t>• Tự xây dựng đề án: Thiết kế đồ gá, chọn thiết bị tự động hóa và lập bảng tính ROI sát thực tế nhà máy.</a:t>
+              <a:t>Tự thiết kế giải pháp: Chế tạo đồ gá, lựa chọn thiết bị tự động hóa và tính toán hiệu quả đầu tư tại chỗ.</a:t>
             </a:r>
           </a:p>
           <a:p>
@@ -16932,7 +16788,7 @@
               </a:defRPr>
             </a:pPr>
             <a:r>
-              <a:t>• Tự thúc đẩy triển khai: Đo kiểm năng lực công đoạn và áp dụng ngay các mục đã được phê duyệt.</a:t>
+              <a:t>Chủ động triển khai: Đo kiểm năng lực công đoạn và áp dụng ngay các nội dung đã được phê duyệt.</a:t>
             </a:r>
           </a:p>
         </p:txBody>
@@ -17069,7 +16925,7 @@
               </a:defRPr>
             </a:pPr>
             <a:r>
-              <a:t>• Quản lý tập trung: Toàn bộ 38 đề án (JP: 7, CN: 11, VN: 20) theo dõi thống nhất trên một file chung.</a:t>
+              <a:t>Quản lý tập trung: Theo dõi đồng bộ toàn bộ 38 đề án (Nhật Bản: 7, Trung Quốc: 11, Việt Nam: 20) trên một tài liệu chung.</a:t>
             </a:r>
           </a:p>
           <a:p>
@@ -17085,7 +16941,7 @@
               </a:defRPr>
             </a:pPr>
             <a:r>
-              <a:t>• Họp định kỳ hàng tuần: Chia sẻ tiến độ, kết quả thực nghiệm và khó khăn phát sinh để cùng tháo gỡ.</a:t>
+              <a:t>Họp định kỳ hàng tuần: Chia sẻ tiến độ thực tế, dữ liệu thực nghiệm và khó khăn phát sinh để cùng tháo gỡ.</a:t>
             </a:r>
           </a:p>
           <a:p>
@@ -17101,7 +16957,7 @@
               </a:defRPr>
             </a:pPr>
             <a:r>
-              <a:t>• Triển khai ngang: Đề án thành công tại một nhà máy được chia sẻ dữ liệu áp dụng cho cả 3 cứ điểm.</a:t>
+              <a:t>Triển khai ngang: Đề án thành công tại một nhà máy được chia sẻ dữ liệu để nhân rộng cho cả ba cứ điểm.</a:t>
             </a:r>
           </a:p>
         </p:txBody>
@@ -17238,7 +17094,7 @@
               </a:defRPr>
             </a:pPr>
             <a:r>
-              <a:t>Phân tích thực tế Line Iris2024 (16 người, 1.083s); chủ động đề xuất 20 giải pháp cải tiến (chiếm 20/38 đề án).</a:t>
+              <a:t>Phân tích thực tế chuyền Iris2024 (16 người, 1.083s); chủ động đề xuất 20 giải pháp cải tiến (chiếm 20/38 đề án của dự án).</a:t>
             </a:r>
           </a:p>
         </p:txBody>
@@ -17375,7 +17231,7 @@
               </a:defRPr>
             </a:pPr>
             <a:r>
-              <a:t>Làm việc trực tiếp với Lắp ráp, QA, Thiết kế và Nhà cung cấp để thực nghiệm, kiểm chứng khả thi và lập BOM chi tiết.</a:t>
+              <a:t>Làm việc trực tiếp với Lắp ráp, QA, Thiết kế và Nhà cung cấp để thực nghiệm, kiểm chứng tính khả thi và lập danh mục BOM chi tiết.</a:t>
             </a:r>
           </a:p>
         </p:txBody>
@@ -17512,7 +17368,7 @@
               </a:defRPr>
             </a:pPr>
             <a:r>
-              <a:t>Tự quản lý tiến độ hàng tháng theo biểu mục tiêu chất lượng PDCA (KDTVN-PE-3), đưa ngay các mục đã chốt vào SOP.</a:t>
+              <a:t>Tự quản lý tiến độ hàng tháng theo biểu mục tiêu chất lượng PDCA (KDTVN-PE-3), đưa ngay các hạng mục đã chốt vào tài liệu SOP.</a:t>
             </a:r>
           </a:p>
         </p:txBody>
@@ -17649,7 +17505,7 @@
               </a:defRPr>
             </a:pPr>
             <a:r>
-              <a:t>Cập nhật đầy đủ kết quả, rủi ro và kiến nghị hỗ trợ vào file chung; báo cáo tại cuộc họp định kỳ 3 cứ điểm.</a:t>
+              <a:t>Cập nhật đầy đủ kết quả, rủi ro và kiến nghị hỗ trợ vào file chung; báo cáo định kỳ tại cuộc họp liên kết ba cứ điểm.</a:t>
             </a:r>
           </a:p>
         </p:txBody>
@@ -17890,7 +17746,7 @@
               </a:defRPr>
             </a:pPr>
             <a:r>
-              <a:t>■ Việt Nam chủ động đề xuất 20 đề án cải tiến; trong đó 3 đề án tự động hóa trong file Iris EXPのVN提案.xlsx có tổng dự toán 855,69 triệu VNĐ (32.911,15 USD).</a:t>
+              <a:t>Việt Nam đã lập 20 đề án cải tiến. Trong đó, 3 đề án tự động hóa theo file Iris EXPのVN提案.xlsx có tổng dự toán 855,69 triệu VNĐ (32.911,15 USD).</a:t>
             </a:r>
           </a:p>
         </p:txBody>
@@ -18703,7 +18559,7 @@
               </a:defRPr>
             </a:pPr>
             <a:r>
-              <a:t>• Đề án 1 (No.22 - Tự động đo an toàn điện, 30s): Chế tạo JIG tự động PLC FX5U + SMC đo khi đóng kín nắp máy, giảm 30s/máy, tiết kiệm 29,6 triệu VNĐ/năm. Đã có báo giá BOM 25 mục: 101.690.000 VNĐ (3.911,15 USD; làm tròn: 4.000 USD).</a:t>
+              <a:t>Đề án 1 (No.22 - Tự động đo an toàn điện, 30s): Chế tạo JIG tự động PLC FX5U và xi lanh SMC đo khi đóng nắp máy. Đã có báo giá BOM 25 mục là 101,69 triệu VNĐ (3.911,15 USD; làm tròn 4.000 USD), tiết kiệm 29,6 triệu VNĐ/năm.</a:t>
             </a:r>
           </a:p>
           <a:p>
@@ -18719,7 +18575,7 @@
               </a:defRPr>
             </a:pPr>
             <a:r>
-              <a:t>• Đề án 2 (No.23 - Tự động đặt bản thảo ISU, 110s): Báo giá Robot 650 triệu VNĐ (25.000 USD). DR4 thống nhất hủy Robot đắt tiền, chuyển sang dùng khay nạp bản gốc DP (No.25) quét liên tục với chi phí thấp.</a:t>
+              <a:t>Đề án 2 (No.23 - Tự động đặt bản thảo ISU, 110s): Báo giá Robot là 650 triệu VNĐ (25.000 USD). Sau DR4, nhóm thống nhất hủy Robot đắt tiền, chuyển sang dùng khay nạp DP (No.25) quét liên tục.</a:t>
             </a:r>
           </a:p>
           <a:p>
@@ -18735,7 +18591,7 @@
               </a:defRPr>
             </a:pPr>
             <a:r>
-              <a:t>• Đề án 3 (No.24 - Kiểm tra USB &amp; tọa độ U201, 30s): Báo giá Robot 104 triệu VNĐ (4.000 USD). Đề xuất hủy Robot, thay bằng đọc log U201 qua Host PC (JP No.3) và xác nhận USB khi nạp FW (JP No.6) với chi phí 0 đồng.</a:t>
+              <a:t>Đề án 3 (No.24 - Kiểm tra USB và tọa độ U201, 30s): Báo giá Robot là 104 triệu VNĐ (4.000 USD). Thống nhất hủy Robot, đọc log U201 qua Host PC (JP No.3) và xác nhận USB khi nạp FW với chi phí 0 đồng.</a:t>
             </a:r>
           </a:p>
           <a:p>
@@ -18751,7 +18607,7 @@
               </a:defRPr>
             </a:pPr>
             <a:r>
-              <a:t>• Đề án 4 (No.25 - Bổ sung khay DP vào máy thực nghiệm): Kéo quét bản in liên tục thay cho đặt tay từng tờ, gửi ảnh về PC tự động chấm điểm.</a:t>
+              <a:t>Đề án 4 (No.25 - Bổ sung khay DP vào máy thực nghiệm): Kéo quét bản in liên tục thay cho đặt tay từng tờ, gửi ảnh về PC tự động chấm điểm.</a:t>
             </a:r>
           </a:p>
         </p:txBody>
@@ -18992,7 +18848,7 @@
               </a:defRPr>
             </a:pPr>
             <a:r>
-              <a:t>■ Các đề án cụm đầu giúp giảm ~173s-185s/máy và giảm 1 người trạm A-1; Đề án No.22 đã có báo giá BOM 25 mục là 101.690.000 VNĐ (3.911,15 USD).</a:t>
+              <a:t>Cụm trạm đầu giảm từ 173s đến 185s mỗi máy, giảm 1 người tại trạm A-1. Đề án No.22 đã hoàn tất báo giá BOM 25 linh kiện với tổng kinh phí 101,69 triệu VNĐ (3.911,15 USD).</a:t>
             </a:r>
           </a:p>
         </p:txBody>
@@ -20224,7 +20080,7 @@
               </a:defRPr>
             </a:pPr>
             <a:r>
-              <a:t>■ Giải quyết nút thắt lớn nhất tại cụm Hình ảnh bằng Quét DP liên tục (No.25 thay Robot No.23) và Camera HIKROBOT đo nồng độ/lề (No.27, giảm 177s~215s/máy).</a:t>
+              <a:t>Khắc phục nút thắt tại cụm Hình ảnh bằng phương án nạp khay DP tự động (No.25 thay thế Robot No.23) và cụm Camera HIKROBOT đo nồng độ màu (No.27, giảm 177s đến 215s/máy).</a:t>
             </a:r>
           </a:p>
         </p:txBody>
@@ -21210,7 +21066,7 @@
               </a:defRPr>
             </a:pPr>
             <a:r>
-              <a:t>• Tổng 3 đề án có giá ban đầu: No.22 (101,69tr) + No.23 Robot ISU (650tr) + No.24 Robot USB/U201 (104tr) = 855,69 triệu VNĐ (32.911,15 USD).</a:t>
+              <a:t>Tổng 3 đề án có giá ban đầu: No.22 (101,69 triệu) + No.23 Robot ISU (650 triệu) + No.24 Robot USB/U201 (104 triệu) = 855,69 triệu VNĐ (32.911,15 USD).</a:t>
             </a:r>
           </a:p>
           <a:p>
@@ -21226,7 +21082,7 @@
               </a:defRPr>
             </a:pPr>
             <a:r>
-              <a:t>• Đề xuất tối ưu sau DR4: Hủy 2 Robot đắt tiền (No.23 &amp; No.24 = 754 triệu VNĐ), thay bằng khay nạp DP No.25 và đọc log Host PC. Đợt 1 chỉ cần duyệt trước Đề án No.22 là 101.690.000 VNĐ (3.911,15 USD) và tập trung ngân sách Đợt 2 cho Camera No.27 (-177s) cùng khay DP No.25.</a:t>
+              <a:t>Phương án tối ưu sau DR4: Hủy 2 Robot đắt tiền (No.23 và No.24 tiết kiệm 754 triệu VNĐ), thay bằng khay nạp DP No.25 và đọc log Host PC. Đợt 1 ưu tiên duyệt trước JIG an toàn điện No.22 là 101,69 triệu VNĐ; Đợt 2 tập trung kinh phí cho Camera No.27 (-177s) và khay DP No.25.</a:t>
             </a:r>
           </a:p>
         </p:txBody>
@@ -21467,7 +21323,7 @@
               </a:defRPr>
             </a:pPr>
             <a:r>
-              <a:t>■ 9 đề án bổ sung tập trung cải tiến mạch/soft tự chẩn đoán và gộp các tờ in test với chi phí thấp; tháng 10/2026 đã hoàn thành xóa 4 bước thao tác trên SOP (-4,32s/máy).</a:t>
+              <a:t>9 đề án bổ sung đợt 2 tập trung chẩn đoán phần mềm và gộp tờ in với chi phí thấp. Trong tháng 10/2026, xưởng đã xóa 4 bước thao tác trên bảng SOP, rút ngắn 4,32s mỗi máy.</a:t>
             </a:r>
           </a:p>
         </p:txBody>

</xml_diff>

<commit_message>
fix(slide3): loai bo tu coi noi, chuyen thanh mat bang co dinh va vi tri thao tac chuan ky thuat san xuat
</commit_message>
<xml_diff>
--- a/Bao_Cao_Dieu_Chinh_IrisEXP_VN.pptx
+++ b/Bao_Cao_Dieu_Chinh_IrisEXP_VN.pptx
@@ -14340,16 +14340,16 @@
           <a:bodyPr rtlCol="0" anchor="ctr" wrap="square" lIns="109728" rIns="109728" tIns="27432" bIns="27432"/>
           <a:lstStyle/>
           <a:p>
-            <a:pPr algn="ctr">
-              <a:defRPr sz="1200" b="1">
-                <a:solidFill>
-                  <a:srgbClr val="1B365D"/>
-                </a:solidFill>
+            <a:pPr>
+              <a:defRPr sz="1200">
                 <a:latin typeface="Times New Roman"/>
               </a:defRPr>
             </a:pPr>
             <a:r>
-              <a:t>Chuyền Điều chỉnh Iris2024 bố trí 11 trạm A1 đến A11 với 16 người thao tác trên diện tích 57m x 2,7m, không còn khả năng cơi nới diện tích hoặc bổ sung người đứng chuyền.</a:t>
+              <a:rPr sz="1200">
+                <a:latin typeface="Times New Roman"/>
+              </a:rPr>
+              <a:t>Chuyền Điều chỉnh Iris2024 bố trí 11 trạm A1 đến A11 với 16 người thao tác trên diện tích 57m × 2,7m; mặt bằng đã cố định, không thể mở rộng diện tích sàn hoặc bổ sung thêm nhân lực đứng chuyền.</a:t>
             </a:r>
           </a:p>
         </p:txBody>
@@ -14978,7 +14978,10 @@
               </a:defRPr>
             </a:pPr>
             <a:r>
-              <a:t>Điểm nghẽn: Quá tải cụm in và đo ảnh; Cell A11 đã giảm từ 6 xuống 5 Cell, không còn chỗ tăng thêm người.</a:t>
+              <a:rPr sz="1200">
+                <a:latin typeface="Times New Roman"/>
+              </a:rPr>
+              <a:t>Điểm nghẽn: Quá tải cụm in và đo ảnh; Cell A11 đã giảm từ 6 xuống 5 Cell, không thể bố trí thêm vị trí thao tác.</a:t>
             </a:r>
           </a:p>
         </p:txBody>

</xml_diff>

<commit_message>
fix(contrast): thiet lap mau chu xanh navy dam 1B365D in dam tren toan bo hop banner slide 1-15, triet de chong chu trang tren nen sang
</commit_message>
<xml_diff>
--- a/Bao_Cao_Dieu_Chinh_IrisEXP_VN.pptx
+++ b/Bao_Cao_Dieu_Chinh_IrisEXP_VN.pptx
@@ -3281,6 +3281,12 @@
               </a:defRPr>
             </a:pPr>
             <a:r>
+              <a:rPr sz="1300" b="1">
+                <a:solidFill>
+                  <a:srgbClr val="1B365D"/>
+                </a:solidFill>
+                <a:latin typeface="Times New Roman"/>
+              </a:rPr>
               <a:t>DỰ ÁN IRIS EXP  |  CÔNG ĐOẠN ĐIỀU CHỈNH</a:t>
             </a:r>
           </a:p>
@@ -3944,6 +3950,12 @@
               </a:defRPr>
             </a:pPr>
             <a:r>
+              <a:rPr sz="1300" b="1">
+                <a:solidFill>
+                  <a:srgbClr val="1B365D"/>
+                </a:solidFill>
+                <a:latin typeface="Times New Roman"/>
+              </a:rPr>
               <a:t>Bộ phận Kỹ thuật Sản xuất KDTVN   |   Người trình bày: Bùi Đức Vinh   |   Tháng 10/2026</a:t>
             </a:r>
           </a:p>
@@ -4185,6 +4197,12 @@
               </a:defRPr>
             </a:pPr>
             <a:r>
+              <a:rPr sz="1200" b="1">
+                <a:solidFill>
+                  <a:srgbClr val="1B365D"/>
+                </a:solidFill>
+                <a:latin typeface="Times New Roman"/>
+              </a:rPr>
               <a:t>Đề xuất phê duyệt Phương án 1 đầu tư JIG đo an toàn điện No.22 (101,69 triệu VNĐ / 3.911,15 USD), hoặc Phương án 2 đầu tư trọn gói cả 3 đề án (855,69 triệu VNĐ / 32.911,15 USD).</a:t>
             </a:r>
           </a:p>
@@ -5620,6 +5638,12 @@
               </a:defRPr>
             </a:pPr>
             <a:r>
+              <a:rPr sz="1200" b="1">
+                <a:solidFill>
+                  <a:srgbClr val="1B365D"/>
+                </a:solidFill>
+                <a:latin typeface="Times New Roman"/>
+              </a:rPr>
               <a:t>Sau cải tiến, năng suất lao động tăng gấp đôi từ 15,19 lên trên 30,38 máy/người/ngày; nhân sự rút gọn còn 8 đến 9 người, đáp ứng yêu cầu sản xuất ngay trên chuyền Iris2024.</a:t>
             </a:r>
           </a:p>
@@ -6994,6 +7018,12 @@
               </a:defRPr>
             </a:pPr>
             <a:r>
+              <a:rPr sz="1200" b="1">
+                <a:solidFill>
+                  <a:srgbClr val="1B365D"/>
+                </a:solidFill>
+                <a:latin typeface="Times New Roman"/>
+              </a:rPr>
               <a:t>Đối chiếu tổng thể số lượng đề án, thời gian cắt giảm, nhân lực và kinh phí giữa ba cứ điểm Nhật Bản, Trung Quốc và Việt Nam.</a:t>
             </a:r>
           </a:p>
@@ -8104,6 +8134,12 @@
               </a:defRPr>
             </a:pPr>
             <a:r>
+              <a:rPr sz="1200" b="1">
+                <a:solidFill>
+                  <a:srgbClr val="1B365D"/>
+                </a:solidFill>
+                <a:latin typeface="Times New Roman"/>
+              </a:rPr>
               <a:t>Danh mục 7 đề án của Nhật Bản và 11 đề án của Trung Quốc theo tài liệu tổng hợp chung, cùng kế hoạch triển khai ngang tại KDTVN.</a:t>
             </a:r>
           </a:p>
@@ -9583,6 +9619,12 @@
               </a:defRPr>
             </a:pPr>
             <a:r>
+              <a:rPr sz="1200" b="1">
+                <a:solidFill>
+                  <a:srgbClr val="1B365D"/>
+                </a:solidFill>
+                <a:latin typeface="Times New Roman"/>
+              </a:rPr>
               <a:t>Tổng hợp 6 vấn đề kỹ thuật và phát sinh chi phí từ 17 cuộc họp liên kết ba cứ điểm, kèm phương án đối sách đã thống nhất sau DR4.</a:t>
             </a:r>
           </a:p>
@@ -10538,6 +10580,12 @@
               </a:defRPr>
             </a:pPr>
             <a:r>
+              <a:rPr sz="1200" b="1">
+                <a:solidFill>
+                  <a:srgbClr val="1B365D"/>
+                </a:solidFill>
+                <a:latin typeface="Times New Roman"/>
+              </a:rPr>
               <a:t>Bảng tra cứu đầy đủ 38 đề án cải tiến của ba cứ điểm được trích xuất từ tài liệu tổng hợp chung IrisEXP改善提案まとめ.xlsx.</a:t>
             </a:r>
           </a:p>
@@ -12991,6 +13039,12 @@
               </a:defRPr>
             </a:pPr>
             <a:r>
+              <a:rPr sz="1200" b="1">
+                <a:solidFill>
+                  <a:srgbClr val="1B365D"/>
+                </a:solidFill>
+                <a:latin typeface="Times New Roman"/>
+              </a:rPr>
               <a:t>Chuyền Iris2024 hiện cần 16 người để đạt 243 máy/ngày (15,19 máy/người). Khi sang IrisEXP theo nhịp Takt 97s (300 máy/ngày), quy trình cũ cần 18 người, vượt quá năng lực mặt bằng hiện có.</a:t>
             </a:r>
           </a:p>
@@ -14340,13 +14394,19 @@
           <a:bodyPr rtlCol="0" anchor="ctr" wrap="square" lIns="109728" rIns="109728" tIns="27432" bIns="27432"/>
           <a:lstStyle/>
           <a:p>
-            <a:pPr>
-              <a:defRPr sz="1200">
+            <a:pPr algn="ctr">
+              <a:defRPr sz="1200" b="1">
+                <a:solidFill>
+                  <a:srgbClr val="1B365D"/>
+                </a:solidFill>
                 <a:latin typeface="Times New Roman"/>
               </a:defRPr>
             </a:pPr>
             <a:r>
-              <a:rPr sz="1200">
+              <a:rPr sz="1200" b="1">
+                <a:solidFill>
+                  <a:srgbClr val="1B365D"/>
+                </a:solidFill>
                 <a:latin typeface="Times New Roman"/>
               </a:rPr>
               <a:t>Chuyền Điều chỉnh Iris2024 bố trí 11 trạm A1 đến A11 với 16 người thao tác trên diện tích 57m × 2,7m; mặt bằng đã cố định, không thể mở rộng diện tích sàn hoặc bổ sung thêm nhân lực đứng chuyền.</a:t>
@@ -15222,6 +15282,12 @@
               </a:defRPr>
             </a:pPr>
             <a:r>
+              <a:rPr sz="1200" b="1">
+                <a:solidFill>
+                  <a:srgbClr val="1B365D"/>
+                </a:solidFill>
+                <a:latin typeface="Times New Roman"/>
+              </a:rPr>
               <a:t>Mục tiêu phát triển của bác Goto: Tăng gấp đôi năng suất (≥30,38 máy/người/ngày), cắt giảm 50% thời gian thao tác và nhân sự, giữ nguyên diện tích chuyền hiện có.</a:t>
             </a:r>
           </a:p>
@@ -16385,6 +16451,12 @@
               </a:defRPr>
             </a:pPr>
             <a:r>
+              <a:rPr sz="1200" b="1">
+                <a:solidFill>
+                  <a:srgbClr val="1B365D"/>
+                </a:solidFill>
+                <a:latin typeface="Times New Roman"/>
+              </a:rPr>
               <a:t>Nhật Bản định hướng thiết kế và điều phối kỹ thuật; Việt Nam và Trung Quốc chủ động xử lý tại xưởng; ba cứ điểm đồng bộ trên tài liệu chung.</a:t>
             </a:r>
           </a:p>
@@ -17749,6 +17821,12 @@
               </a:defRPr>
             </a:pPr>
             <a:r>
+              <a:rPr sz="1200" b="1">
+                <a:solidFill>
+                  <a:srgbClr val="1B365D"/>
+                </a:solidFill>
+                <a:latin typeface="Times New Roman"/>
+              </a:rPr>
               <a:t>Việt Nam đã lập 20 đề án cải tiến. Trong đó, 3 đề án tự động hóa theo file Iris EXPのVN提案.xlsx có tổng dự toán 855,69 triệu VNĐ (32.911,15 USD).</a:t>
             </a:r>
           </a:p>
@@ -18851,6 +18929,12 @@
               </a:defRPr>
             </a:pPr>
             <a:r>
+              <a:rPr sz="1200" b="1">
+                <a:solidFill>
+                  <a:srgbClr val="1B365D"/>
+                </a:solidFill>
+                <a:latin typeface="Times New Roman"/>
+              </a:rPr>
               <a:t>Cụm trạm đầu giảm từ 173s đến 185s mỗi máy, giảm 1 người tại trạm A-1. Đề án No.22 đã hoàn tất báo giá BOM 25 linh kiện với tổng kinh phí 101,69 triệu VNĐ (3.911,15 USD).</a:t>
             </a:r>
           </a:p>
@@ -20083,6 +20167,12 @@
               </a:defRPr>
             </a:pPr>
             <a:r>
+              <a:rPr sz="1200" b="1">
+                <a:solidFill>
+                  <a:srgbClr val="1B365D"/>
+                </a:solidFill>
+                <a:latin typeface="Times New Roman"/>
+              </a:rPr>
               <a:t>Khắc phục nút thắt tại cụm Hình ảnh bằng phương án nạp khay DP tự động (No.25 thay thế Robot No.23) và cụm Camera HIKROBOT đo nồng độ màu (No.27, giảm 177s đến 215s/máy).</a:t>
             </a:r>
           </a:p>
@@ -21326,6 +21416,12 @@
               </a:defRPr>
             </a:pPr>
             <a:r>
+              <a:rPr sz="1200" b="1">
+                <a:solidFill>
+                  <a:srgbClr val="1B365D"/>
+                </a:solidFill>
+                <a:latin typeface="Times New Roman"/>
+              </a:rPr>
               <a:t>9 đề án bổ sung đợt 2 tập trung chẩn đoán phần mềm và gộp tờ in với chi phí thấp. Trong tháng 10/2026, xưởng đã xóa 4 bước thao tác trên bảng SOP, rút ngắn 4,32s mỗi máy.</a:t>
             </a:r>
           </a:p>

</xml_diff>

<commit_message>
feat: update Slide 5 layout and integrate FW Partner proposal on Slide 6 in VN and JP decks
</commit_message>
<xml_diff>
--- a/Bao_Cao_Dieu_Chinh_IrisEXP_VN.pptx
+++ b/Bao_Cao_Dieu_Chinh_IrisEXP_VN.pptx
@@ -16756,7 +16756,7 @@
         <p:spPr>
           <a:xfrm>
             <a:off x="256032" y="2103120"/>
-            <a:ext cx="3767328" cy="2103120"/>
+            <a:ext cx="3767328" cy="3750000"/>
           </a:xfrm>
           <a:prstGeom prst="rect">
             <a:avLst/>
@@ -16802,7 +16802,7 @@
         <p:spPr>
           <a:xfrm>
             <a:off x="256032" y="2103120"/>
-            <a:ext cx="3767328" cy="347472"/>
+            <a:ext cx="3767328" cy="360000"/>
           </a:xfrm>
           <a:prstGeom prst="rect">
             <a:avLst/>
@@ -16854,8 +16854,8 @@
         </p:nvSpPr>
         <p:spPr>
           <a:xfrm>
-            <a:off x="347472" y="2487168"/>
-            <a:ext cx="3584448" cy="1682495"/>
+            <a:off x="320000" y="2520000"/>
+            <a:ext cx="3640000" cy="3250000"/>
           </a:xfrm>
           <a:prstGeom prst="rect">
             <a:avLst/>
@@ -16863,14 +16863,17 @@
           <a:noFill/>
         </p:spPr>
         <p:txBody>
-          <a:bodyPr wrap="square" lIns="36576" tIns="18288" rIns="36576" bIns="18288">
+          <a:bodyPr wrap="square" lIns="109728" tIns="109728" rIns="109728" bIns="109728">
             <a:spAutoFit/>
           </a:bodyPr>
           <a:lstStyle/>
           <a:p>
             <a:pPr>
+              <a:lnSpc>
+                <a:spcPct val="125000"/>
+              </a:lnSpc>
               <a:spcAft>
-                <a:spcPts val="300"/>
+                <a:spcPts val="1400"/>
               </a:spcAft>
               <a:defRPr sz="1200">
                 <a:solidFill>
@@ -16880,39 +16883,105 @@
               </a:defRPr>
             </a:pPr>
             <a:r>
-              <a:t>Định hướng thiết kế tổng thể: Xây dựng cấu trúc chuẩn công đoạn Bảo chứng thân máy và lộ trình kỹ thuật.</a:t>
-            </a:r>
-          </a:p>
-          <a:p>
-            <a:pPr>
-              <a:spcAft>
-                <a:spcPts val="300"/>
-              </a:spcAft>
-              <a:defRPr sz="1200">
+              <a:rPr sz="1300" b="1">
+                <a:solidFill>
+                  <a:srgbClr val="1B365D"/>
+                </a:solidFill>
+                <a:latin typeface="Times New Roman"/>
+              </a:rPr>
+              <a:t>• </a:t>
+            </a:r>
+            <a:r>
+              <a:rPr sz="1300" b="1">
+                <a:solidFill>
+                  <a:srgbClr val="1B365D"/>
+                </a:solidFill>
+                <a:latin typeface="Times New Roman"/>
+              </a:rPr>
+              <a:t>Định hướng thiết kế tổng thể: </a:t>
+            </a:r>
+            <a:r>
+              <a:rPr sz="1300" b="0">
                 <a:solidFill>
                   <a:srgbClr val="1E242B"/>
                 </a:solidFill>
                 <a:latin typeface="Times New Roman"/>
-              </a:defRPr>
+              </a:rPr>
+              <a:t>Xây dựng cấu trúc chuẩn công đoạn Bảo chứng thân máy và lộ trình kỹ thuật cho toàn dự án IrisEXP.</a:t>
+            </a:r>
+          </a:p>
+          <a:p>
+            <a:pPr>
+              <a:lnSpc>
+                <a:spcPct val="125000"/>
+              </a:lnSpc>
+              <a:spcAft>
+                <a:spcPts val="1400"/>
+              </a:spcAft>
             </a:pPr>
             <a:r>
-              <a:t>Đánh giá và phê duyệt: Thẩm định tính khả thi và phê duyệt tiêu chuẩn kỹ thuật QA cho các đề án từ nhà máy.</a:t>
-            </a:r>
-          </a:p>
-          <a:p>
-            <a:pPr>
-              <a:spcAft>
-                <a:spcPts val="300"/>
-              </a:spcAft>
-              <a:defRPr sz="1200">
+              <a:rPr sz="1300" b="1">
+                <a:solidFill>
+                  <a:srgbClr val="1B365D"/>
+                </a:solidFill>
+                <a:latin typeface="Times New Roman"/>
+              </a:rPr>
+              <a:t>• </a:t>
+            </a:r>
+            <a:r>
+              <a:rPr sz="1300" b="1">
+                <a:solidFill>
+                  <a:srgbClr val="1B365D"/>
+                </a:solidFill>
+                <a:latin typeface="Times New Roman"/>
+              </a:rPr>
+              <a:t>Đánh giá và phê duyệt: </a:t>
+            </a:r>
+            <a:r>
+              <a:rPr sz="1300" b="0">
                 <a:solidFill>
                   <a:srgbClr val="1E242B"/>
                 </a:solidFill>
                 <a:latin typeface="Times New Roman"/>
-              </a:defRPr>
+              </a:rPr>
+              <a:t>Thẩm định tính khả thi, đánh giá an toàn chất lượng và phê duyệt tiêu chuẩn QA cho các đề án cải tiến từ nhà máy.</a:t>
+            </a:r>
+          </a:p>
+          <a:p>
+            <a:pPr>
+              <a:lnSpc>
+                <a:spcPct val="125000"/>
+              </a:lnSpc>
+              <a:spcAft>
+                <a:spcPts val="1400"/>
+              </a:spcAft>
             </a:pPr>
             <a:r>
-              <a:t>Điều phối kỹ thuật: Kết nối các bộ phận Thiết kế, Phần mềm, QA và Kỹ thuật sản xuất xử lý vướng mắc.</a:t>
+              <a:rPr sz="1300" b="1">
+                <a:solidFill>
+                  <a:srgbClr val="1B365D"/>
+                </a:solidFill>
+                <a:latin typeface="Times New Roman"/>
+              </a:rPr>
+              <a:t>• </a:t>
+            </a:r>
+            <a:r>
+              <a:rPr sz="1300" b="1">
+                <a:solidFill>
+                  <a:srgbClr val="1B365D"/>
+                </a:solidFill>
+                <a:latin typeface="Times New Roman"/>
+              </a:rPr>
+              <a:t>Điều phối kỹ thuật liên bộ phận: </a:t>
+            </a:r>
+            <a:r>
+              <a:rPr sz="1300" b="0">
+                <a:solidFill>
+                  <a:srgbClr val="1E242B"/>
+                </a:solidFill>
+                <a:latin typeface="Times New Roman"/>
+              </a:rPr>
+              <a:t>Kết nối chặt chẽ giữa Thiết kế, Phần mềm, QA và Kỹ thuật sản xuất nhằm tháo gỡ nhanh các rào cản kỹ thuật.</a:t>
             </a:r>
           </a:p>
         </p:txBody>
@@ -16926,7 +16995,7 @@
         <p:spPr>
           <a:xfrm>
             <a:off x="4206240" y="2103120"/>
-            <a:ext cx="3767328" cy="2103120"/>
+            <a:ext cx="3767328" cy="3750000"/>
           </a:xfrm>
           <a:prstGeom prst="rect">
             <a:avLst/>
@@ -16972,7 +17041,7 @@
         <p:spPr>
           <a:xfrm>
             <a:off x="4206240" y="2103120"/>
-            <a:ext cx="3767328" cy="347472"/>
+            <a:ext cx="3767328" cy="360000"/>
           </a:xfrm>
           <a:prstGeom prst="rect">
             <a:avLst/>
@@ -17024,8 +17093,8 @@
         </p:nvSpPr>
         <p:spPr>
           <a:xfrm>
-            <a:off x="4297679" y="2487168"/>
-            <a:ext cx="3584448" cy="1682495"/>
+            <a:off x="4270000" y="2520000"/>
+            <a:ext cx="3640000" cy="3250000"/>
           </a:xfrm>
           <a:prstGeom prst="rect">
             <a:avLst/>
@@ -17033,14 +17102,17 @@
           <a:noFill/>
         </p:spPr>
         <p:txBody>
-          <a:bodyPr wrap="square" lIns="36576" tIns="18288" rIns="36576" bIns="18288">
+          <a:bodyPr wrap="square" lIns="109728" tIns="109728" rIns="109728" bIns="109728">
             <a:spAutoFit/>
           </a:bodyPr>
           <a:lstStyle/>
           <a:p>
             <a:pPr>
+              <a:lnSpc>
+                <a:spcPct val="125000"/>
+              </a:lnSpc>
               <a:spcAft>
-                <a:spcPts val="300"/>
+                <a:spcPts val="1400"/>
               </a:spcAft>
               <a:defRPr sz="1200">
                 <a:solidFill>
@@ -17050,39 +17122,105 @@
               </a:defRPr>
             </a:pPr>
             <a:r>
-              <a:t>Chủ động phát hiện vấn đề: Bấm giờ thao tác, phân tích video và bóc tách điểm nghẽn thực tế trên chuyền.</a:t>
-            </a:r>
-          </a:p>
-          <a:p>
-            <a:pPr>
-              <a:spcAft>
-                <a:spcPts val="300"/>
-              </a:spcAft>
-              <a:defRPr sz="1200">
+              <a:rPr sz="1300" b="1">
+                <a:solidFill>
+                  <a:srgbClr val="1B365D"/>
+                </a:solidFill>
+                <a:latin typeface="Times New Roman"/>
+              </a:rPr>
+              <a:t>• </a:t>
+            </a:r>
+            <a:r>
+              <a:rPr sz="1300" b="1">
+                <a:solidFill>
+                  <a:srgbClr val="1B365D"/>
+                </a:solidFill>
+                <a:latin typeface="Times New Roman"/>
+              </a:rPr>
+              <a:t>Chủ động phát hiện vấn đề: </a:t>
+            </a:r>
+            <a:r>
+              <a:rPr sz="1300" b="0">
                 <a:solidFill>
                   <a:srgbClr val="1E242B"/>
                 </a:solidFill>
                 <a:latin typeface="Times New Roman"/>
-              </a:defRPr>
+              </a:rPr>
+              <a:t>Bấm giờ thao tác thực tế, phân tích video bóc tách điểm nghẽn tại 11 trạm điều chỉnh (chu kỳ 1.083s).</a:t>
+            </a:r>
+          </a:p>
+          <a:p>
+            <a:pPr>
+              <a:lnSpc>
+                <a:spcPct val="125000"/>
+              </a:lnSpc>
+              <a:spcAft>
+                <a:spcPts val="1400"/>
+              </a:spcAft>
             </a:pPr>
             <a:r>
-              <a:t>Tự thiết kế giải pháp: Chế tạo đồ gá, lựa chọn thiết bị tự động hóa và tính toán hiệu quả đầu tư tại chỗ.</a:t>
-            </a:r>
-          </a:p>
-          <a:p>
-            <a:pPr>
-              <a:spcAft>
-                <a:spcPts val="300"/>
-              </a:spcAft>
-              <a:defRPr sz="1200">
+              <a:rPr sz="1300" b="1">
+                <a:solidFill>
+                  <a:srgbClr val="1B365D"/>
+                </a:solidFill>
+                <a:latin typeface="Times New Roman"/>
+              </a:rPr>
+              <a:t>• </a:t>
+            </a:r>
+            <a:r>
+              <a:rPr sz="1300" b="1">
+                <a:solidFill>
+                  <a:srgbClr val="1B365D"/>
+                </a:solidFill>
+                <a:latin typeface="Times New Roman"/>
+              </a:rPr>
+              <a:t>Tự thiết kế &amp; kiểm chứng: </a:t>
+            </a:r>
+            <a:r>
+              <a:rPr sz="1300" b="0">
                 <a:solidFill>
                   <a:srgbClr val="1E242B"/>
                 </a:solidFill>
                 <a:latin typeface="Times New Roman"/>
-              </a:defRPr>
+              </a:rPr>
+              <a:t>Chế tạo đồ gá nội bộ, chuyển đổi dùng khay DP thay thế Robot đắt tiền, tính toán hiệu quả đầu tư tại chỗ.</a:t>
+            </a:r>
+          </a:p>
+          <a:p>
+            <a:pPr>
+              <a:lnSpc>
+                <a:spcPct val="125000"/>
+              </a:lnSpc>
+              <a:spcAft>
+                <a:spcPts val="1400"/>
+              </a:spcAft>
             </a:pPr>
             <a:r>
-              <a:t>Chủ động triển khai: Đo kiểm năng lực công đoạn và áp dụng ngay các nội dung đã được phê duyệt.</a:t>
+              <a:rPr sz="1300" b="1">
+                <a:solidFill>
+                  <a:srgbClr val="1B365D"/>
+                </a:solidFill>
+                <a:latin typeface="Times New Roman"/>
+              </a:rPr>
+              <a:t>• </a:t>
+            </a:r>
+            <a:r>
+              <a:rPr sz="1300" b="1">
+                <a:solidFill>
+                  <a:srgbClr val="1B365D"/>
+                </a:solidFill>
+                <a:latin typeface="Times New Roman"/>
+              </a:rPr>
+              <a:t>Chủ động triển khai: </a:t>
+            </a:r>
+            <a:r>
+              <a:rPr sz="1300" b="0">
+                <a:solidFill>
+                  <a:srgbClr val="1E242B"/>
+                </a:solidFill>
+                <a:latin typeface="Times New Roman"/>
+              </a:rPr>
+              <a:t>Tự theo dõi tiến độ PDCA hàng tháng, đo kiểm năng lực công đoạn và áp dụng ngay các cải tiến đã chốt vào tài liệu SOP.</a:t>
             </a:r>
           </a:p>
         </p:txBody>
@@ -17096,7 +17234,7 @@
         <p:spPr>
           <a:xfrm>
             <a:off x="8156448" y="2103120"/>
-            <a:ext cx="3779215" cy="2103120"/>
+            <a:ext cx="3779215" cy="3750000"/>
           </a:xfrm>
           <a:prstGeom prst="rect">
             <a:avLst/>
@@ -17142,7 +17280,7 @@
         <p:spPr>
           <a:xfrm>
             <a:off x="8156448" y="2103120"/>
-            <a:ext cx="3779215" cy="347472"/>
+            <a:ext cx="3779215" cy="360000"/>
           </a:xfrm>
           <a:prstGeom prst="rect">
             <a:avLst/>
@@ -17194,8 +17332,8 @@
         </p:nvSpPr>
         <p:spPr>
           <a:xfrm>
-            <a:off x="8247888" y="2487168"/>
-            <a:ext cx="3596335" cy="1682495"/>
+            <a:off x="8220000" y="2520000"/>
+            <a:ext cx="3650000" cy="3250000"/>
           </a:xfrm>
           <a:prstGeom prst="rect">
             <a:avLst/>
@@ -17203,14 +17341,17 @@
           <a:noFill/>
         </p:spPr>
         <p:txBody>
-          <a:bodyPr wrap="square" lIns="36576" tIns="18288" rIns="36576" bIns="18288">
+          <a:bodyPr wrap="square" lIns="109728" tIns="109728" rIns="109728" bIns="109728">
             <a:spAutoFit/>
           </a:bodyPr>
           <a:lstStyle/>
           <a:p>
             <a:pPr>
+              <a:lnSpc>
+                <a:spcPct val="125000"/>
+              </a:lnSpc>
               <a:spcAft>
-                <a:spcPts val="300"/>
+                <a:spcPts val="1400"/>
               </a:spcAft>
               <a:defRPr sz="1200">
                 <a:solidFill>
@@ -17220,39 +17361,105 @@
               </a:defRPr>
             </a:pPr>
             <a:r>
-              <a:t>Quản lý tập trung: Theo dõi đồng bộ toàn bộ 38 đề án (Nhật Bản: 7, Trung Quốc: 11, Việt Nam: 20) trên một tài liệu chung.</a:t>
-            </a:r>
-          </a:p>
-          <a:p>
-            <a:pPr>
-              <a:spcAft>
-                <a:spcPts val="300"/>
-              </a:spcAft>
-              <a:defRPr sz="1200">
+              <a:rPr sz="1300" b="1">
+                <a:solidFill>
+                  <a:srgbClr val="1B365D"/>
+                </a:solidFill>
+                <a:latin typeface="Times New Roman"/>
+              </a:rPr>
+              <a:t>• </a:t>
+            </a:r>
+            <a:r>
+              <a:rPr sz="1300" b="1">
+                <a:solidFill>
+                  <a:srgbClr val="1B365D"/>
+                </a:solidFill>
+                <a:latin typeface="Times New Roman"/>
+              </a:rPr>
+              <a:t>Quản lý tập trung: </a:t>
+            </a:r>
+            <a:r>
+              <a:rPr sz="1300" b="0">
                 <a:solidFill>
                   <a:srgbClr val="1E242B"/>
                 </a:solidFill>
                 <a:latin typeface="Times New Roman"/>
-              </a:defRPr>
+              </a:rPr>
+              <a:t>Theo dõi đồng bộ toàn bộ 38 đề án (Nhật Bản: 7, Trung Quốc: 11, Việt Nam: 20) trên cùng một bảng quản lý chung.</a:t>
+            </a:r>
+          </a:p>
+          <a:p>
+            <a:pPr>
+              <a:lnSpc>
+                <a:spcPct val="125000"/>
+              </a:lnSpc>
+              <a:spcAft>
+                <a:spcPts val="1400"/>
+              </a:spcAft>
             </a:pPr>
             <a:r>
-              <a:t>Họp định kỳ hàng tuần: Chia sẻ tiến độ thực tế, dữ liệu thực nghiệm và khó khăn phát sinh để cùng tháo gỡ.</a:t>
-            </a:r>
-          </a:p>
-          <a:p>
-            <a:pPr>
-              <a:spcAft>
-                <a:spcPts val="300"/>
-              </a:spcAft>
-              <a:defRPr sz="1200">
+              <a:rPr sz="1300" b="1">
+                <a:solidFill>
+                  <a:srgbClr val="1B365D"/>
+                </a:solidFill>
+                <a:latin typeface="Times New Roman"/>
+              </a:rPr>
+              <a:t>• </a:t>
+            </a:r>
+            <a:r>
+              <a:rPr sz="1300" b="1">
+                <a:solidFill>
+                  <a:srgbClr val="1B365D"/>
+                </a:solidFill>
+                <a:latin typeface="Times New Roman"/>
+              </a:rPr>
+              <a:t>Họp định kỳ hàng tuần: </a:t>
+            </a:r>
+            <a:r>
+              <a:rPr sz="1300" b="0">
                 <a:solidFill>
                   <a:srgbClr val="1E242B"/>
                 </a:solidFill>
                 <a:latin typeface="Times New Roman"/>
-              </a:defRPr>
+              </a:rPr>
+              <a:t>Họp liên kết ba cứ điểm để chia sẻ tiến độ thực tế, nộp dữ liệu thực nghiệm và cùng nhau giải quyết vướng mắc.</a:t>
+            </a:r>
+          </a:p>
+          <a:p>
+            <a:pPr>
+              <a:lnSpc>
+                <a:spcPct val="125000"/>
+              </a:lnSpc>
+              <a:spcAft>
+                <a:spcPts val="1400"/>
+              </a:spcAft>
             </a:pPr>
             <a:r>
-              <a:t>Triển khai ngang: Đề án thành công tại một nhà máy được chia sẻ dữ liệu để nhân rộng cho cả ba cứ điểm.</a:t>
+              <a:rPr sz="1300" b="1">
+                <a:solidFill>
+                  <a:srgbClr val="1B365D"/>
+                </a:solidFill>
+                <a:latin typeface="Times New Roman"/>
+              </a:rPr>
+              <a:t>• </a:t>
+            </a:r>
+            <a:r>
+              <a:rPr sz="1300" b="1">
+                <a:solidFill>
+                  <a:srgbClr val="1B365D"/>
+                </a:solidFill>
+                <a:latin typeface="Times New Roman"/>
+              </a:rPr>
+              <a:t>Nhân rộng giải pháp: </a:t>
+            </a:r>
+            <a:r>
+              <a:rPr sz="1300" b="0">
+                <a:solidFill>
+                  <a:srgbClr val="1E242B"/>
+                </a:solidFill>
+                <a:latin typeface="Times New Roman"/>
+              </a:rPr>
+              <a:t>Đề án cải tiến thành công tại một nhà máy được chia sẻ dữ liệu và chuyển giao tiêu chuẩn để nhân rộng cho cả ba cứ điểm.</a:t>
             </a:r>
           </a:p>
         </p:txBody>
@@ -17265,18 +17472,18 @@
         </p:nvSpPr>
         <p:spPr>
           <a:xfrm>
-            <a:off x="256032" y="4315968"/>
-            <a:ext cx="2852928" cy="2176272"/>
+            <a:off x="256032" y="5980000"/>
+            <a:ext cx="11679631" cy="520000"/>
           </a:xfrm>
           <a:prstGeom prst="rect">
             <a:avLst/>
           </a:prstGeom>
           <a:solidFill>
-            <a:srgbClr val="FFFFFF"/>
+            <a:srgbClr val="E8EEF5"/>
           </a:solidFill>
           <a:ln w="12700">
             <a:solidFill>
-              <a:srgbClr val="C5CDD6"/>
+              <a:srgbClr val="1B365D"/>
             </a:solidFill>
           </a:ln>
         </p:spPr>
@@ -17295,516 +17502,18 @@
           </a:fontRef>
         </p:style>
         <p:txBody>
-          <a:bodyPr rtlCol="0" anchor="ctr"/>
+          <a:bodyPr rtlCol="0" anchor="ctr" wrap="square" tIns="73152" bIns="73152"/>
           <a:lstStyle/>
           <a:p>
             <a:pPr algn="ctr"/>
-            <a:endParaRPr/>
-          </a:p>
-        </p:txBody>
-      </p:sp>
-      <p:sp>
-        <p:nvSpPr>
-          <p:cNvPr id="18" name="Rectangle 17"/>
-          <p:cNvSpPr/>
-          <p:nvPr/>
-        </p:nvSpPr>
-        <p:spPr>
-          <a:xfrm>
-            <a:off x="256032" y="4315968"/>
-            <a:ext cx="2852928" cy="347472"/>
-          </a:xfrm>
-          <a:prstGeom prst="rect">
-            <a:avLst/>
-          </a:prstGeom>
-          <a:solidFill>
-            <a:srgbClr val="1E6E3E"/>
-          </a:solidFill>
-          <a:ln>
-            <a:noFill/>
-          </a:ln>
-        </p:spPr>
-        <p:style>
-          <a:lnRef idx="1">
-            <a:schemeClr val="accent1"/>
-          </a:lnRef>
-          <a:fillRef idx="3">
-            <a:schemeClr val="accent1"/>
-          </a:fillRef>
-          <a:effectRef idx="2">
-            <a:schemeClr val="accent1"/>
-          </a:effectRef>
-          <a:fontRef idx="minor">
-            <a:schemeClr val="lt1"/>
-          </a:fontRef>
-        </p:style>
-        <p:txBody>
-          <a:bodyPr wrap="square" tIns="27432" rtlCol="0" anchor="ctr"/>
-          <a:lstStyle/>
-          <a:p>
-            <a:pPr algn="ctr">
-              <a:defRPr sz="1250" b="1">
+            <a:r>
+              <a:rPr sz="1300" b="1">
                 <a:solidFill>
-                  <a:srgbClr val="FFFFFF"/>
+                  <a:srgbClr val="1B365D"/>
                 </a:solidFill>
                 <a:latin typeface="Times New Roman"/>
-              </a:defRPr>
-            </a:pPr>
-            <a:r>
-              <a:t>BƯỚC 1: PHÂN TÍCH &amp; ĐỀ XUẤT</a:t>
-            </a:r>
-          </a:p>
-        </p:txBody>
-      </p:sp>
-      <p:sp>
-        <p:nvSpPr>
-          <p:cNvPr id="19" name="TextBox 18"/>
-          <p:cNvSpPr txBox="1"/>
-          <p:nvPr/>
-        </p:nvSpPr>
-        <p:spPr>
-          <a:xfrm>
-            <a:off x="347472" y="4700016"/>
-            <a:ext cx="2670048" cy="1755648"/>
-          </a:xfrm>
-          <a:prstGeom prst="rect">
-            <a:avLst/>
-          </a:prstGeom>
-          <a:noFill/>
-        </p:spPr>
-        <p:txBody>
-          <a:bodyPr wrap="square" lIns="36576" tIns="18288" rIns="36576" bIns="18288">
-            <a:spAutoFit/>
-          </a:bodyPr>
-          <a:lstStyle/>
-          <a:p>
-            <a:pPr>
-              <a:spcAft>
-                <a:spcPts val="300"/>
-              </a:spcAft>
-              <a:defRPr sz="1200">
-                <a:solidFill>
-                  <a:srgbClr val="1E242B"/>
-                </a:solidFill>
-                <a:latin typeface="Times New Roman"/>
-              </a:defRPr>
-            </a:pPr>
-            <a:r>
-              <a:t>Phân tích thực tế chuyền Iris2024 (16 người, 1.083s); chủ động đề xuất 20 giải pháp cải tiến (chiếm 20/38 đề án của dự án).</a:t>
-            </a:r>
-          </a:p>
-        </p:txBody>
-      </p:sp>
-      <p:sp>
-        <p:nvSpPr>
-          <p:cNvPr id="20" name="Rectangle 19"/>
-          <p:cNvSpPr/>
-          <p:nvPr/>
-        </p:nvSpPr>
-        <p:spPr>
-          <a:xfrm>
-            <a:off x="3209544" y="4315968"/>
-            <a:ext cx="2852928" cy="2176272"/>
-          </a:xfrm>
-          <a:prstGeom prst="rect">
-            <a:avLst/>
-          </a:prstGeom>
-          <a:solidFill>
-            <a:srgbClr val="FFFFFF"/>
-          </a:solidFill>
-          <a:ln w="12700">
-            <a:solidFill>
-              <a:srgbClr val="C5CDD6"/>
-            </a:solidFill>
-          </a:ln>
-        </p:spPr>
-        <p:style>
-          <a:lnRef idx="1">
-            <a:schemeClr val="accent1"/>
-          </a:lnRef>
-          <a:fillRef idx="3">
-            <a:schemeClr val="accent1"/>
-          </a:fillRef>
-          <a:effectRef idx="2">
-            <a:schemeClr val="accent1"/>
-          </a:effectRef>
-          <a:fontRef idx="minor">
-            <a:schemeClr val="lt1"/>
-          </a:fontRef>
-        </p:style>
-        <p:txBody>
-          <a:bodyPr rtlCol="0" anchor="ctr"/>
-          <a:lstStyle/>
-          <a:p>
-            <a:pPr algn="ctr"/>
-            <a:endParaRPr/>
-          </a:p>
-        </p:txBody>
-      </p:sp>
-      <p:sp>
-        <p:nvSpPr>
-          <p:cNvPr id="21" name="Rectangle 20"/>
-          <p:cNvSpPr/>
-          <p:nvPr/>
-        </p:nvSpPr>
-        <p:spPr>
-          <a:xfrm>
-            <a:off x="3209544" y="4315968"/>
-            <a:ext cx="2852928" cy="347472"/>
-          </a:xfrm>
-          <a:prstGeom prst="rect">
-            <a:avLst/>
-          </a:prstGeom>
-          <a:solidFill>
-            <a:srgbClr val="1E6E3E"/>
-          </a:solidFill>
-          <a:ln>
-            <a:noFill/>
-          </a:ln>
-        </p:spPr>
-        <p:style>
-          <a:lnRef idx="1">
-            <a:schemeClr val="accent1"/>
-          </a:lnRef>
-          <a:fillRef idx="3">
-            <a:schemeClr val="accent1"/>
-          </a:fillRef>
-          <a:effectRef idx="2">
-            <a:schemeClr val="accent1"/>
-          </a:effectRef>
-          <a:fontRef idx="minor">
-            <a:schemeClr val="lt1"/>
-          </a:fontRef>
-        </p:style>
-        <p:txBody>
-          <a:bodyPr wrap="square" tIns="27432" rtlCol="0" anchor="ctr"/>
-          <a:lstStyle/>
-          <a:p>
-            <a:pPr algn="ctr">
-              <a:defRPr sz="1250" b="1">
-                <a:solidFill>
-                  <a:srgbClr val="FFFFFF"/>
-                </a:solidFill>
-                <a:latin typeface="Times New Roman"/>
-              </a:defRPr>
-            </a:pPr>
-            <a:r>
-              <a:t>BƯỚC 2: PHỐI HỢP KIỂM CHỨNG</a:t>
-            </a:r>
-          </a:p>
-        </p:txBody>
-      </p:sp>
-      <p:sp>
-        <p:nvSpPr>
-          <p:cNvPr id="22" name="TextBox 21"/>
-          <p:cNvSpPr txBox="1"/>
-          <p:nvPr/>
-        </p:nvSpPr>
-        <p:spPr>
-          <a:xfrm>
-            <a:off x="3300984" y="4700016"/>
-            <a:ext cx="2670048" cy="1755648"/>
-          </a:xfrm>
-          <a:prstGeom prst="rect">
-            <a:avLst/>
-          </a:prstGeom>
-          <a:noFill/>
-        </p:spPr>
-        <p:txBody>
-          <a:bodyPr wrap="square" lIns="36576" tIns="18288" rIns="36576" bIns="18288">
-            <a:spAutoFit/>
-          </a:bodyPr>
-          <a:lstStyle/>
-          <a:p>
-            <a:pPr>
-              <a:spcAft>
-                <a:spcPts val="300"/>
-              </a:spcAft>
-              <a:defRPr sz="1200">
-                <a:solidFill>
-                  <a:srgbClr val="1E242B"/>
-                </a:solidFill>
-                <a:latin typeface="Times New Roman"/>
-              </a:defRPr>
-            </a:pPr>
-            <a:r>
-              <a:t>Làm việc trực tiếp với Lắp ráp, QA, Thiết kế và Nhà cung cấp để thực nghiệm, kiểm chứng tính khả thi và lập danh mục BOM chi tiết.</a:t>
-            </a:r>
-          </a:p>
-        </p:txBody>
-      </p:sp>
-      <p:sp>
-        <p:nvSpPr>
-          <p:cNvPr id="23" name="Rectangle 22"/>
-          <p:cNvSpPr/>
-          <p:nvPr/>
-        </p:nvSpPr>
-        <p:spPr>
-          <a:xfrm>
-            <a:off x="6163056" y="4315968"/>
-            <a:ext cx="2852928" cy="2176272"/>
-          </a:xfrm>
-          <a:prstGeom prst="rect">
-            <a:avLst/>
-          </a:prstGeom>
-          <a:solidFill>
-            <a:srgbClr val="FFFFFF"/>
-          </a:solidFill>
-          <a:ln w="12700">
-            <a:solidFill>
-              <a:srgbClr val="C5CDD6"/>
-            </a:solidFill>
-          </a:ln>
-        </p:spPr>
-        <p:style>
-          <a:lnRef idx="1">
-            <a:schemeClr val="accent1"/>
-          </a:lnRef>
-          <a:fillRef idx="3">
-            <a:schemeClr val="accent1"/>
-          </a:fillRef>
-          <a:effectRef idx="2">
-            <a:schemeClr val="accent1"/>
-          </a:effectRef>
-          <a:fontRef idx="minor">
-            <a:schemeClr val="lt1"/>
-          </a:fontRef>
-        </p:style>
-        <p:txBody>
-          <a:bodyPr rtlCol="0" anchor="ctr"/>
-          <a:lstStyle/>
-          <a:p>
-            <a:pPr algn="ctr"/>
-            <a:endParaRPr/>
-          </a:p>
-        </p:txBody>
-      </p:sp>
-      <p:sp>
-        <p:nvSpPr>
-          <p:cNvPr id="24" name="Rectangle 23"/>
-          <p:cNvSpPr/>
-          <p:nvPr/>
-        </p:nvSpPr>
-        <p:spPr>
-          <a:xfrm>
-            <a:off x="6163056" y="4315968"/>
-            <a:ext cx="2852928" cy="347472"/>
-          </a:xfrm>
-          <a:prstGeom prst="rect">
-            <a:avLst/>
-          </a:prstGeom>
-          <a:solidFill>
-            <a:srgbClr val="1E6E3E"/>
-          </a:solidFill>
-          <a:ln>
-            <a:noFill/>
-          </a:ln>
-        </p:spPr>
-        <p:style>
-          <a:lnRef idx="1">
-            <a:schemeClr val="accent1"/>
-          </a:lnRef>
-          <a:fillRef idx="3">
-            <a:schemeClr val="accent1"/>
-          </a:fillRef>
-          <a:effectRef idx="2">
-            <a:schemeClr val="accent1"/>
-          </a:effectRef>
-          <a:fontRef idx="minor">
-            <a:schemeClr val="lt1"/>
-          </a:fontRef>
-        </p:style>
-        <p:txBody>
-          <a:bodyPr wrap="square" tIns="27432" rtlCol="0" anchor="ctr"/>
-          <a:lstStyle/>
-          <a:p>
-            <a:pPr algn="ctr">
-              <a:defRPr sz="1250" b="1">
-                <a:solidFill>
-                  <a:srgbClr val="FFFFFF"/>
-                </a:solidFill>
-                <a:latin typeface="Times New Roman"/>
-              </a:defRPr>
-            </a:pPr>
-            <a:r>
-              <a:t>BƯỚC 3: TỰ THEO DÕI TIẾN ĐỘ</a:t>
-            </a:r>
-          </a:p>
-        </p:txBody>
-      </p:sp>
-      <p:sp>
-        <p:nvSpPr>
-          <p:cNvPr id="25" name="TextBox 24"/>
-          <p:cNvSpPr txBox="1"/>
-          <p:nvPr/>
-        </p:nvSpPr>
-        <p:spPr>
-          <a:xfrm>
-            <a:off x="6254496" y="4700016"/>
-            <a:ext cx="2670048" cy="1755648"/>
-          </a:xfrm>
-          <a:prstGeom prst="rect">
-            <a:avLst/>
-          </a:prstGeom>
-          <a:noFill/>
-        </p:spPr>
-        <p:txBody>
-          <a:bodyPr wrap="square" lIns="36576" tIns="18288" rIns="36576" bIns="18288">
-            <a:spAutoFit/>
-          </a:bodyPr>
-          <a:lstStyle/>
-          <a:p>
-            <a:pPr>
-              <a:spcAft>
-                <a:spcPts val="300"/>
-              </a:spcAft>
-              <a:defRPr sz="1200">
-                <a:solidFill>
-                  <a:srgbClr val="1E242B"/>
-                </a:solidFill>
-                <a:latin typeface="Times New Roman"/>
-              </a:defRPr>
-            </a:pPr>
-            <a:r>
-              <a:t>Tự quản lý tiến độ hàng tháng theo biểu mục tiêu chất lượng PDCA (KDTVN-PE-3), đưa ngay các hạng mục đã chốt vào tài liệu SOP.</a:t>
-            </a:r>
-          </a:p>
-        </p:txBody>
-      </p:sp>
-      <p:sp>
-        <p:nvSpPr>
-          <p:cNvPr id="26" name="Rectangle 25"/>
-          <p:cNvSpPr/>
-          <p:nvPr/>
-        </p:nvSpPr>
-        <p:spPr>
-          <a:xfrm>
-            <a:off x="9116567" y="4315968"/>
-            <a:ext cx="2852928" cy="2176272"/>
-          </a:xfrm>
-          <a:prstGeom prst="rect">
-            <a:avLst/>
-          </a:prstGeom>
-          <a:solidFill>
-            <a:srgbClr val="FFFFFF"/>
-          </a:solidFill>
-          <a:ln w="12700">
-            <a:solidFill>
-              <a:srgbClr val="C5CDD6"/>
-            </a:solidFill>
-          </a:ln>
-        </p:spPr>
-        <p:style>
-          <a:lnRef idx="1">
-            <a:schemeClr val="accent1"/>
-          </a:lnRef>
-          <a:fillRef idx="3">
-            <a:schemeClr val="accent1"/>
-          </a:fillRef>
-          <a:effectRef idx="2">
-            <a:schemeClr val="accent1"/>
-          </a:effectRef>
-          <a:fontRef idx="minor">
-            <a:schemeClr val="lt1"/>
-          </a:fontRef>
-        </p:style>
-        <p:txBody>
-          <a:bodyPr rtlCol="0" anchor="ctr"/>
-          <a:lstStyle/>
-          <a:p>
-            <a:pPr algn="ctr"/>
-            <a:endParaRPr/>
-          </a:p>
-        </p:txBody>
-      </p:sp>
-      <p:sp>
-        <p:nvSpPr>
-          <p:cNvPr id="27" name="Rectangle 26"/>
-          <p:cNvSpPr/>
-          <p:nvPr/>
-        </p:nvSpPr>
-        <p:spPr>
-          <a:xfrm>
-            <a:off x="9116567" y="4315968"/>
-            <a:ext cx="2852928" cy="347472"/>
-          </a:xfrm>
-          <a:prstGeom prst="rect">
-            <a:avLst/>
-          </a:prstGeom>
-          <a:solidFill>
-            <a:srgbClr val="1E6E3E"/>
-          </a:solidFill>
-          <a:ln>
-            <a:noFill/>
-          </a:ln>
-        </p:spPr>
-        <p:style>
-          <a:lnRef idx="1">
-            <a:schemeClr val="accent1"/>
-          </a:lnRef>
-          <a:fillRef idx="3">
-            <a:schemeClr val="accent1"/>
-          </a:fillRef>
-          <a:effectRef idx="2">
-            <a:schemeClr val="accent1"/>
-          </a:effectRef>
-          <a:fontRef idx="minor">
-            <a:schemeClr val="lt1"/>
-          </a:fontRef>
-        </p:style>
-        <p:txBody>
-          <a:bodyPr wrap="square" tIns="27432" rtlCol="0" anchor="ctr"/>
-          <a:lstStyle/>
-          <a:p>
-            <a:pPr algn="ctr">
-              <a:defRPr sz="1250" b="1">
-                <a:solidFill>
-                  <a:srgbClr val="FFFFFF"/>
-                </a:solidFill>
-                <a:latin typeface="Times New Roman"/>
-              </a:defRPr>
-            </a:pPr>
-            <a:r>
-              <a:t>BƯỚC 4: CẬP NHẬT &amp; BÁO CÁO</a:t>
-            </a:r>
-          </a:p>
-        </p:txBody>
-      </p:sp>
-      <p:sp>
-        <p:nvSpPr>
-          <p:cNvPr id="28" name="TextBox 27"/>
-          <p:cNvSpPr txBox="1"/>
-          <p:nvPr/>
-        </p:nvSpPr>
-        <p:spPr>
-          <a:xfrm>
-            <a:off x="9208007" y="4700016"/>
-            <a:ext cx="2670048" cy="1755648"/>
-          </a:xfrm>
-          <a:prstGeom prst="rect">
-            <a:avLst/>
-          </a:prstGeom>
-          <a:noFill/>
-        </p:spPr>
-        <p:txBody>
-          <a:bodyPr wrap="square" lIns="36576" tIns="18288" rIns="36576" bIns="18288">
-            <a:spAutoFit/>
-          </a:bodyPr>
-          <a:lstStyle/>
-          <a:p>
-            <a:pPr>
-              <a:spcAft>
-                <a:spcPts val="300"/>
-              </a:spcAft>
-              <a:defRPr sz="1200">
-                <a:solidFill>
-                  <a:srgbClr val="1E242B"/>
-                </a:solidFill>
-                <a:latin typeface="Times New Roman"/>
-              </a:defRPr>
-            </a:pPr>
-            <a:r>
-              <a:t>Cập nhật đầy đủ kết quả, rủi ro và kiến nghị hỗ trợ vào file chung; báo cáo định kỳ tại cuộc họp liên kết ba cứ điểm.</a:t>
+              </a:rPr>
+              <a:t>Mục tiêu phối hợp: KDC định hướng kiến trúc, Nhà máy làm chủ hiện trường, ba cứ điểm đồng bộ dữ liệu quyết tâm đạt mục tiêu Takt Time IrisEXP.</a:t>
             </a:r>
           </a:p>
         </p:txBody>
@@ -17954,7 +17663,7 @@
           <a:lstStyle/>
           <a:p>
             <a:pPr>
-              <a:defRPr sz="1550" b="1">
+              <a:defRPr sz="1400" b="1">
                 <a:solidFill>
                   <a:srgbClr val="FFFFFF"/>
                 </a:solidFill>
@@ -17962,7 +17671,7 @@
               </a:defRPr>
             </a:pPr>
             <a:r>
-              <a:t>Tổng quan 20 đề án cải tiến của Việt Nam (No.18 ~ No.37) và 4 hạng mục tự động hóa</a:t>
+              <a:t>Tổng quan 20 đề án cải tiến của Việt Nam (No.18 ~ No.37) và các đề án trọng tâm</a:t>
             </a:r>
           </a:p>
         </p:txBody>
@@ -18022,7 +17731,7 @@
           </a:solidFill>
           <a:ln w="12700">
             <a:solidFill>
-              <a:srgbClr val="2B547E"/>
+              <a:srgbClr val="1B365D"/>
             </a:solidFill>
           </a:ln>
         </p:spPr>
@@ -18053,13 +17762,7 @@
               </a:defRPr>
             </a:pPr>
             <a:r>
-              <a:rPr sz="1200" b="1">
-                <a:solidFill>
-                  <a:srgbClr val="1B365D"/>
-                </a:solidFill>
-                <a:latin typeface="Times New Roman"/>
-              </a:rPr>
-              <a:t>Việt Nam đã lập 20 đề án cải tiến. Trong đó, 3 đề án tự động hóa theo file Iris EXPのVN提案.xlsx có tổng dự toán 855,69 triệu VNĐ (32.911,15 USD).</a:t>
+              <a:t>Việt Nam lập 20 đề án: Trọng tâm chuyển nạp Soft về NCC (giảm 1 người tại A-1) và 4 hạng mục tự động hóa với dự toán duyệt 101,69 triệu VNĐ (No.22).</a:t>
             </a:r>
           </a:p>
         </p:txBody>
@@ -18802,8 +18505,8 @@
         </p:nvSpPr>
         <p:spPr>
           <a:xfrm>
-            <a:off x="256032" y="3977639"/>
-            <a:ext cx="11679631" cy="2514600"/>
+            <a:off x="256032" y="3980000"/>
+            <a:ext cx="5739815" cy="2580000"/>
           </a:xfrm>
           <a:prstGeom prst="rect">
             <a:avLst/>
@@ -18813,7 +18516,7 @@
           </a:solidFill>
           <a:ln w="12700">
             <a:solidFill>
-              <a:srgbClr val="C5CDD6"/>
+              <a:srgbClr val="D0D7DE"/>
             </a:solidFill>
           </a:ln>
         </p:spPr>
@@ -18836,7 +18539,6 @@
           <a:lstStyle/>
           <a:p>
             <a:pPr algn="ctr"/>
-            <a:endParaRPr/>
           </a:p>
         </p:txBody>
       </p:sp>
@@ -18848,8 +18550,8 @@
         </p:nvSpPr>
         <p:spPr>
           <a:xfrm>
-            <a:off x="256032" y="3977639"/>
-            <a:ext cx="11679631" cy="347472"/>
+            <a:off x="256032" y="3980000"/>
+            <a:ext cx="5739815" cy="330000"/>
           </a:xfrm>
           <a:prstGeom prst="rect">
             <a:avLst/>
@@ -18858,7 +18560,9 @@
             <a:srgbClr val="1B365D"/>
           </a:solidFill>
           <a:ln>
-            <a:noFill/>
+            <a:solidFill>
+              <a:srgbClr val="1B365D"/>
+            </a:solidFill>
           </a:ln>
         </p:spPr>
         <p:style>
@@ -18876,11 +18580,11 @@
           </a:fontRef>
         </p:style>
         <p:txBody>
-          <a:bodyPr wrap="square" tIns="27432" rtlCol="0" anchor="ctr"/>
+          <a:bodyPr rtlCol="0" anchor="ctr"/>
           <a:lstStyle/>
           <a:p>
             <a:pPr algn="ctr">
-              <a:defRPr sz="1250" b="1">
+              <a:defRPr sz="1200" b="1">
                 <a:solidFill>
                   <a:srgbClr val="FFFFFF"/>
                 </a:solidFill>
@@ -18888,7 +18592,7 @@
               </a:defRPr>
             </a:pPr>
             <a:r>
-              <a:t>CƠ CẤU 4 HẠNG MỤC TỰ ĐỘNG HÓA TRONG FILE DỰ TOÁN IRIS EXPのVN提案.xlsx (TỶ GIÁ 26.000 VNĐ/USD)</a:t>
+              <a:t>CƠ CẤU 4 HẠNG MỤC TỰ ĐỘNG HÓA TRONG FILE DỰ TOÁN VN</a:t>
             </a:r>
           </a:p>
         </p:txBody>
@@ -18901,8 +18605,8 @@
         </p:nvSpPr>
         <p:spPr>
           <a:xfrm>
-            <a:off x="347472" y="4361688"/>
-            <a:ext cx="11496751" cy="2093976"/>
+            <a:off x="296032" y="4325000"/>
+            <a:ext cx="5659815" cy="2225000"/>
           </a:xfrm>
           <a:prstGeom prst="rect">
             <a:avLst/>
@@ -18910,72 +18614,327 @@
           <a:noFill/>
         </p:spPr>
         <p:txBody>
-          <a:bodyPr wrap="square" lIns="36576" tIns="18288" rIns="36576" bIns="18288">
+          <a:bodyPr wrap="square" lIns="54864" rIns="54864" tIns="36576" bIns="36576">
             <a:spAutoFit/>
           </a:bodyPr>
           <a:lstStyle/>
           <a:p>
             <a:pPr>
+              <a:lnSpc>
+                <a:spcPct val="115000"/>
+              </a:lnSpc>
               <a:spcAft>
-                <a:spcPts val="300"/>
+                <a:spcPts val="600"/>
               </a:spcAft>
-              <a:defRPr sz="1200">
+            </a:pPr>
+            <a:r>
+              <a:rPr sz="1200" b="1">
+                <a:solidFill>
+                  <a:srgbClr val="1B365D"/>
+                </a:solidFill>
+                <a:latin typeface="Times New Roman"/>
+              </a:rPr>
+              <a:t>• Đề án 1 (No.22 - Đo an toàn điện, 30s): </a:t>
+            </a:r>
+            <a:r>
+              <a:rPr sz="1200" b="0">
                 <a:solidFill>
                   <a:srgbClr val="1E242B"/>
                 </a:solidFill>
                 <a:latin typeface="Times New Roman"/>
-              </a:defRPr>
+              </a:rPr>
+              <a:t>JIG tự động PLC FX5U đo khi đóng nắp máy. BOM 25 mục: 101,69 tr VNĐ (3.911 USD), tiết kiệm 29,6 tr/năm (đề nghị duyệt Đợt 1).</a:t>
+            </a:r>
+          </a:p>
+          <a:p>
+            <a:pPr>
+              <a:lnSpc>
+                <a:spcPct val="115000"/>
+              </a:lnSpc>
+              <a:spcAft>
+                <a:spcPts val="600"/>
+              </a:spcAft>
             </a:pPr>
             <a:r>
-              <a:t>Đề án 1 (No.22 - Tự động đo an toàn điện, 30s): Chế tạo JIG tự động PLC FX5U và xi lanh SMC đo khi đóng nắp máy. Đã có báo giá BOM 25 mục là 101,69 triệu VNĐ (3.911,15 USD; làm tròn 4.000 USD), tiết kiệm 29,6 triệu VNĐ/năm.</a:t>
-            </a:r>
-          </a:p>
-          <a:p>
-            <a:pPr>
-              <a:spcAft>
-                <a:spcPts val="300"/>
-              </a:spcAft>
-              <a:defRPr sz="1200">
+              <a:rPr sz="1200" b="1">
+                <a:solidFill>
+                  <a:srgbClr val="1B365D"/>
+                </a:solidFill>
+                <a:latin typeface="Times New Roman"/>
+              </a:rPr>
+              <a:t>• Đề án 2 &amp; 3 (Hủy Robot ISU &amp; USB, 140s): </a:t>
+            </a:r>
+            <a:r>
+              <a:rPr sz="1200" b="0">
                 <a:solidFill>
                   <a:srgbClr val="1E242B"/>
                 </a:solidFill>
                 <a:latin typeface="Times New Roman"/>
-              </a:defRPr>
+              </a:rPr>
+              <a:t>Hủy 2 Robot đắt tiền (tiết kiệm 754 tr VNĐ / 29.000 USD). Thay bằng khay nạp DP (No.25) và đọc log qua mạng Host PC với chi phí 0đ.</a:t>
+            </a:r>
+          </a:p>
+          <a:p>
+            <a:pPr>
+              <a:lnSpc>
+                <a:spcPct val="115000"/>
+              </a:lnSpc>
+              <a:spcAft>
+                <a:spcPts val="600"/>
+              </a:spcAft>
             </a:pPr>
             <a:r>
-              <a:t>Đề án 2 (No.23 - Tự động đặt bản thảo ISU, 110s): Báo giá Robot là 650 triệu VNĐ (25.000 USD). Sau DR4, nhóm thống nhất hủy Robot đắt tiền, chuyển sang dùng khay nạp DP (No.25) quét liên tục.</a:t>
-            </a:r>
-          </a:p>
-          <a:p>
-            <a:pPr>
-              <a:spcAft>
-                <a:spcPts val="300"/>
-              </a:spcAft>
-              <a:defRPr sz="1200">
+              <a:rPr sz="1200" b="1">
+                <a:solidFill>
+                  <a:srgbClr val="1B365D"/>
+                </a:solidFill>
+                <a:latin typeface="Times New Roman"/>
+              </a:rPr>
+              <a:t>• Đề án 4 (No.25 - Khay nạp DP thực nghiệm): </a:t>
+            </a:r>
+            <a:r>
+              <a:rPr sz="1200" b="0">
                 <a:solidFill>
                   <a:srgbClr val="1E242B"/>
                 </a:solidFill>
                 <a:latin typeface="Times New Roman"/>
+              </a:rPr>
+              <a:t>Quét bản in liên tục thay cho đặt tay từng tờ, truyền ảnh về máy tính để tự động kiểm tra và chấm điểm sai lệch hình ảnh.</a:t>
+            </a:r>
+          </a:p>
+        </p:txBody>
+      </p:sp>
+      <p:sp>
+        <p:nvSpPr>
+          <p:cNvPr id="12" name="Rectangle 11"/>
+          <p:cNvSpPr/>
+          <p:nvPr/>
+        </p:nvSpPr>
+        <p:spPr>
+          <a:xfrm>
+            <a:off x="6195847" y="3980000"/>
+            <a:ext cx="5739815" cy="2580000"/>
+          </a:xfrm>
+          <a:prstGeom prst="rect">
+            <a:avLst/>
+          </a:prstGeom>
+          <a:solidFill>
+            <a:srgbClr val="FFFFFF"/>
+          </a:solidFill>
+          <a:ln w="12700">
+            <a:solidFill>
+              <a:srgbClr val="D0D7DE"/>
+            </a:solidFill>
+          </a:ln>
+        </p:spPr>
+        <p:style>
+          <a:lnRef idx="1">
+            <a:schemeClr val="accent1"/>
+          </a:lnRef>
+          <a:fillRef idx="3">
+            <a:schemeClr val="accent1"/>
+          </a:fillRef>
+          <a:effectRef idx="2">
+            <a:schemeClr val="accent1"/>
+          </a:effectRef>
+          <a:fontRef idx="minor">
+            <a:schemeClr val="lt1"/>
+          </a:fontRef>
+        </p:style>
+        <p:txBody>
+          <a:bodyPr rtlCol="0" anchor="ctr"/>
+          <a:lstStyle/>
+          <a:p>
+            <a:pPr algn="ctr"/>
+          </a:p>
+        </p:txBody>
+      </p:sp>
+      <p:sp>
+        <p:nvSpPr>
+          <p:cNvPr id="13" name="Rectangle 12"/>
+          <p:cNvSpPr/>
+          <p:nvPr/>
+        </p:nvSpPr>
+        <p:spPr>
+          <a:xfrm>
+            <a:off x="6195847" y="3980000"/>
+            <a:ext cx="5739815" cy="330000"/>
+          </a:xfrm>
+          <a:prstGeom prst="rect">
+            <a:avLst/>
+          </a:prstGeom>
+          <a:solidFill>
+            <a:srgbClr val="005A70"/>
+          </a:solidFill>
+          <a:ln>
+            <a:solidFill>
+              <a:srgbClr val="005A70"/>
+            </a:solidFill>
+          </a:ln>
+        </p:spPr>
+        <p:style>
+          <a:lnRef idx="1">
+            <a:schemeClr val="accent1"/>
+          </a:lnRef>
+          <a:fillRef idx="3">
+            <a:schemeClr val="accent1"/>
+          </a:fillRef>
+          <a:effectRef idx="2">
+            <a:schemeClr val="accent1"/>
+          </a:effectRef>
+          <a:fontRef idx="minor">
+            <a:schemeClr val="lt1"/>
+          </a:fontRef>
+        </p:style>
+        <p:txBody>
+          <a:bodyPr rtlCol="0" anchor="ctr"/>
+          <a:lstStyle/>
+          <a:p>
+            <a:pPr algn="ctr">
+              <a:defRPr sz="1200" b="1">
+                <a:solidFill>
+                  <a:srgbClr val="FFFFFF"/>
+                </a:solidFill>
+                <a:latin typeface="Times New Roman"/>
               </a:defRPr>
             </a:pPr>
             <a:r>
-              <a:t>Đề án 3 (No.24 - Kiểm tra USB và tọa độ U201, 30s): Báo giá Robot là 104 triệu VNĐ (4.000 USD). Thống nhất hủy Robot, đọc log U201 qua Host PC (JP No.3) và xác nhận USB khi nạp FW với chi phí 0 đồng.</a:t>
-            </a:r>
-          </a:p>
+              <a:t>ĐỀ ÁN TRỌNG ĐIỂM: CHUYỂN NẠP SOFT VỀ NCC / PARTNER (TRẠM A-1)</a:t>
+            </a:r>
+          </a:p>
+        </p:txBody>
+      </p:sp>
+      <p:sp>
+        <p:nvSpPr>
+          <p:cNvPr id="14" name="TextBox 13"/>
+          <p:cNvSpPr txBox="1"/>
+          <p:nvPr/>
+        </p:nvSpPr>
+        <p:spPr>
+          <a:xfrm>
+            <a:off x="6235847" y="4325000"/>
+            <a:ext cx="5659815" cy="2225000"/>
+          </a:xfrm>
+          <a:prstGeom prst="rect">
+            <a:avLst/>
+          </a:prstGeom>
+          <a:noFill/>
+        </p:spPr>
+        <p:txBody>
+          <a:bodyPr wrap="square" lIns="54864" rIns="54864" tIns="36576" bIns="36576">
+            <a:spAutoFit/>
+          </a:bodyPr>
+          <a:lstStyle/>
           <a:p>
             <a:pPr>
+              <a:lnSpc>
+                <a:spcPct val="112000"/>
+              </a:lnSpc>
               <a:spcAft>
-                <a:spcPts val="300"/>
+                <a:spcPts val="400"/>
               </a:spcAft>
-              <a:defRPr sz="1200">
+            </a:pPr>
+            <a:r>
+              <a:rPr sz="1200" b="1">
+                <a:solidFill>
+                  <a:srgbClr val="005A70"/>
+                </a:solidFill>
+                <a:latin typeface="Times New Roman"/>
+              </a:rPr>
+              <a:t>• Mục tiêu: </a:t>
+            </a:r>
+            <a:r>
+              <a:rPr sz="1200" b="0">
                 <a:solidFill>
                   <a:srgbClr val="1E242B"/>
                 </a:solidFill>
                 <a:latin typeface="Times New Roman"/>
-              </a:defRPr>
+              </a:rPr>
+              <a:t>Hủy nạp soft tại Line, nạp trước tại Partner/NCC để giảm chu kỳ sản xuất, giảm công đoạn và giảm 1 người thao tác (mục tiêu x2 năng suất).</a:t>
+            </a:r>
+          </a:p>
+          <a:p>
+            <a:pPr>
+              <a:lnSpc>
+                <a:spcPct val="112000"/>
+              </a:lnSpc>
+              <a:spcAft>
+                <a:spcPts val="400"/>
+              </a:spcAft>
             </a:pPr>
             <a:r>
-              <a:t>Đề án 4 (No.25 - Bổ sung khay DP vào máy thực nghiệm): Kéo quét bản in liên tục thay cho đặt tay từng tờ, gửi ảnh về PC tự động chấm điểm.</a:t>
+              <a:rPr sz="1200" b="1">
+                <a:solidFill>
+                  <a:srgbClr val="005A70"/>
+                </a:solidFill>
+                <a:latin typeface="Times New Roman"/>
+              </a:rPr>
+              <a:t>• Phương án: </a:t>
+            </a:r>
+            <a:r>
+              <a:rPr sz="1200" b="0">
+                <a:solidFill>
+                  <a:srgbClr val="1E242B"/>
+                </a:solidFill>
+                <a:latin typeface="Times New Roman"/>
+              </a:rPr>
+              <a:t>Nạp trước Main, Language, OCR, Engine, Motor, Panel, AI. Tại chuyền chỉ đối chiếu version qua Set Serial để chống lọt lỗi ra thị trường.</a:t>
+            </a:r>
+          </a:p>
+          <a:p>
+            <a:pPr>
+              <a:lnSpc>
+                <a:spcPct val="112000"/>
+              </a:lnSpc>
+              <a:spcAft>
+                <a:spcPts val="400"/>
+              </a:spcAft>
+            </a:pPr>
+            <a:r>
+              <a:rPr sz="1200" b="1">
+                <a:solidFill>
+                  <a:srgbClr val="005A70"/>
+                </a:solidFill>
+                <a:latin typeface="Times New Roman"/>
+              </a:rPr>
+              <a:t>• Điều kiện &amp; Thách thức: </a:t>
+            </a:r>
+            <a:r>
+              <a:rPr sz="1200" b="0">
+                <a:solidFill>
+                  <a:srgbClr val="1E242B"/>
+                </a:solidFill>
+                <a:latin typeface="Times New Roman"/>
+              </a:rPr>
+              <a:t>Quản lý chặt bản mạch Old/New khi đổi Program; khó dùng chung Main board do khác biệt LSU, SSD, xuất TQ (tăng chi phí nếu nâng cấu hình).</a:t>
+            </a:r>
+          </a:p>
+          <a:p>
+            <a:pPr>
+              <a:lnSpc>
+                <a:spcPct val="112000"/>
+              </a:lnSpc>
+              <a:spcAft>
+                <a:spcPts val="400"/>
+              </a:spcAft>
+            </a:pPr>
+            <a:r>
+              <a:rPr sz="1200" b="1">
+                <a:solidFill>
+                  <a:srgbClr val="005A70"/>
+                </a:solidFill>
+                <a:latin typeface="Times New Roman"/>
+              </a:rPr>
+              <a:t>• Định hướng (Bác Hanazaki): </a:t>
+            </a:r>
+            <a:r>
+              <a:rPr sz="1200" b="0">
+                <a:solidFill>
+                  <a:srgbClr val="1E242B"/>
+                </a:solidFill>
+                <a:latin typeface="Times New Roman"/>
+              </a:rPr>
+              <a:t>Tập trung vào hiệu quả giảm người thực tế trên line thay vì chỉ giảm vài phút thao tác; cân đối chi phí và công việc tại khâu linh kiện.</a:t>
             </a:r>
           </a:p>
         </p:txBody>
@@ -21141,16 +21100,16 @@
                     <a:bodyPr/>
                     <a:lstStyle/>
                     <a:p>
-                      <a:pPr algn="l">
-                        <a:defRPr sz="1200">
-                          <a:solidFill>
-                            <a:srgbClr val="1E242B"/>
-                          </a:solidFill>
-                          <a:latin typeface="Times New Roman"/>
-                        </a:defRPr>
-                      </a:pPr>
-                      <a:r>
-                        <a:t>Chỉ nạp lại soft khi có phiên bản mới cập nhật sau xuất xưởng; bình thường Skip và đối chiếu Version qua Set Serial.</a:t>
+                      <a:pPr>
+                        <a:defRPr sz="1100">
+                          <a:solidFill>
+                            <a:srgbClr val="1E242B"/>
+                          </a:solidFill>
+                          <a:latin typeface="Times New Roman"/>
+                        </a:defRPr>
+                      </a:pPr>
+                      <a:r>
+                        <a:t>Nạp trước toàn bộ F/W (Main, Lang, OCR, Engine, Motor, Panel, AI) tại NCC; tại Line chỉ đối chiếu version qua Set Serial. Quản lý chặt bản mạch Old/New và đánh giá hiệu quả giảm người thực tế theo chỉ đạo bác Hanazaki.</a:t>
                       </a:r>
                     </a:p>
                   </a:txBody>
@@ -21165,20 +21124,16 @@
                     <a:bodyPr/>
                     <a:lstStyle/>
                     <a:p>
-                      <a:pPr algn="l">
-                        <a:defRPr sz="1200">
-                          <a:solidFill>
-                            <a:srgbClr val="1E242B"/>
-                          </a:solidFill>
-                          <a:latin typeface="Times New Roman"/>
-                        </a:defRPr>
-                      </a:pPr>
-                      <a:r>
-                        <a:t>Giảm 13s ~ 25s thao tác tay;</a:t>
-                      </a:r>
-                      <a:br/>
-                      <a:r>
-                        <a:t>Giảm 1 người tại trạm A-1</a:t>
+                      <a:pPr>
+                        <a:defRPr sz="1100">
+                          <a:solidFill>
+                            <a:srgbClr val="1E242B"/>
+                          </a:solidFill>
+                          <a:latin typeface="Times New Roman"/>
+                        </a:defRPr>
+                      </a:pPr>
+                      <a:r>
+                        <a:t>Giảm 13s ~ 25s thao tác; Hướng tới cắt giảm 1 người tại trạm A-1 (đóng góp mục tiêu x2 năng suất)</a:t>
                       </a:r>
                     </a:p>
                   </a:txBody>
@@ -21193,20 +21148,16 @@
                     <a:bodyPr/>
                     <a:lstStyle/>
                     <a:p>
-                      <a:pPr algn="l">
-                        <a:defRPr sz="1200">
-                          <a:solidFill>
-                            <a:srgbClr val="1E242B"/>
-                          </a:solidFill>
-                          <a:latin typeface="Times New Roman"/>
-                        </a:defRPr>
-                      </a:pPr>
-                      <a:r>
-                        <a:t>0 VNĐ thiết bị</a:t>
-                      </a:r>
-                      <a:br/>
-                      <a:r>
-                        <a:t>(Đang chốt với Thiết kế JP)</a:t>
+                      <a:pPr>
+                        <a:defRPr sz="1100">
+                          <a:solidFill>
+                            <a:srgbClr val="1E242B"/>
+                          </a:solidFill>
+                          <a:latin typeface="Times New Roman"/>
+                        </a:defRPr>
+                      </a:pPr>
+                      <a:r>
+                        <a:t>0 VNĐ thiết bị (Đang chốt cơ chế Old/New và giới hạn dùng chung Main board với Thiết kế JP)</a:t>
                       </a:r>
                     </a:p>
                   </a:txBody>

</xml_diff>

<commit_message>
feat: update Slide 4 Card 3 layout and sync to Japanese presentation
</commit_message>
<xml_diff>
--- a/Bao_Cao_Dieu_Chinh_IrisEXP_VN.pptx
+++ b/Bao_Cao_Dieu_Chinh_IrisEXP_VN.pptx
@@ -16278,12 +16278,15 @@
           <a:noFill/>
         </p:spPr>
         <p:txBody>
-          <a:bodyPr wrap="square" lIns="36576" tIns="18288" rIns="36576" bIns="18288">
+          <a:bodyPr wrap="square" lIns="109728" tIns="109728" rIns="109728" bIns="109728">
             <a:spAutoFit/>
           </a:bodyPr>
           <a:lstStyle/>
           <a:p>
             <a:pPr>
+              <a:spcBef>
+                <a:spcPts val="0"/>
+              </a:spcBef>
               <a:spcAft>
                 <a:spcPts val="200"/>
               </a:spcAft>
@@ -16295,63 +16298,117 @@
               </a:defRPr>
             </a:pPr>
             <a:r>
-              <a:t>Tự động hóa 7 cụm thao tác:</a:t>
+              <a:rPr sz="1300" b="1">
+                <a:solidFill>
+                  <a:srgbClr val="1B5E20"/>
+                </a:solidFill>
+                <a:latin typeface="Times New Roman"/>
+              </a:rPr>
+              <a:t>Năng suất lao động (Tăng gấp đôi):</a:t>
             </a:r>
           </a:p>
           <a:p>
             <a:pPr>
+              <a:lnSpc>
+                <a:spcPct val="120000"/>
+              </a:lnSpc>
+              <a:spcBef>
+                <a:spcPts val="0"/>
+              </a:spcBef>
               <a:spcAft>
-                <a:spcPts val="1200"/>
+                <a:spcPts val="800"/>
               </a:spcAft>
-              <a:defRPr sz="1250">
+            </a:pPr>
+            <a:r>
+              <a:rPr sz="1250" b="0">
                 <a:solidFill>
                   <a:srgbClr val="1E242B"/>
                 </a:solidFill>
                 <a:latin typeface="Times New Roman"/>
-              </a:defRPr>
-            </a:pPr>
-            <a:r>
-              <a:t>Triển khai JIG an toàn điện, Camera đo màu, khay nạp DP tự động và phần mềm mạng Spica.</a:t>
+              </a:rPr>
+              <a:t>Đạt ≥ 30,38 ~ 33,33 máy/người/ngày (tăng gấp đôi so với hiện tại: 15,19 máy/người/ngày).</a:t>
             </a:r>
           </a:p>
           <a:p>
             <a:pPr>
+              <a:spcBef>
+                <a:spcPts val="800"/>
+              </a:spcBef>
               <a:spcAft>
                 <a:spcPts val="200"/>
               </a:spcAft>
-              <a:defRPr sz="1300" b="1">
+            </a:pPr>
+            <a:r>
+              <a:rPr sz="1300" b="1">
                 <a:solidFill>
-                  <a:srgbClr val="1B365D"/>
+                  <a:srgbClr val="1B5E20"/>
                 </a:solidFill>
                 <a:latin typeface="Times New Roman"/>
-              </a:defRPr>
+              </a:rPr>
+              <a:t>Tinh gọn nhân sự (Cắt giảm 50%):</a:t>
+            </a:r>
+          </a:p>
+          <a:p>
+            <a:pPr>
+              <a:lnSpc>
+                <a:spcPct val="120000"/>
+              </a:lnSpc>
+              <a:spcBef>
+                <a:spcPts val="0"/>
+              </a:spcBef>
+              <a:spcAft>
+                <a:spcPts val="800"/>
+              </a:spcAft>
             </a:pPr>
             <a:r>
-              <a:t>Mục tiêu năng suất tại KDTVN:</a:t>
-            </a:r>
-          </a:p>
-          <a:p>
-            <a:pPr>
-              <a:spcAft>
-                <a:spcPts val="0"/>
-              </a:spcAft>
-              <a:defRPr sz="1250">
+              <a:rPr sz="1250" b="0">
                 <a:solidFill>
                   <a:srgbClr val="1E242B"/>
                 </a:solidFill>
                 <a:latin typeface="Times New Roman"/>
-              </a:defRPr>
+              </a:rPr>
+              <a:t>Rút gọn quy mô nhân lực từ 16 ~ 18 người xuống còn 8 ~ 9 người vận hành trên toàn chuyền.</a:t>
+            </a:r>
+          </a:p>
+          <a:p>
+            <a:pPr>
+              <a:spcBef>
+                <a:spcPts val="800"/>
+              </a:spcBef>
+              <a:spcAft>
+                <a:spcPts val="200"/>
+              </a:spcAft>
             </a:pPr>
             <a:r>
-              <a:t>• Năng suất 1 người tăng gấp đôi: Đạt ≥ 30,38 ~ 33,33 máy/người/ngày (hiện tại: 15,19 máy).</a:t>
-            </a:r>
-            <a:br/>
-            <a:r>
-              <a:t>• Tinh gọn nhân sự 50%: Rút gọn từ 16 ~ 18 người xuống còn 8 ~ 9 người đứng chuyền.</a:t>
-            </a:r>
-            <a:br/>
-            <a:r>
-              <a:t>• Năng lực công đoạn: Đạt Cpk ≥ 1,33 khi sản xuất hàng loạt MP.</a:t>
+              <a:rPr sz="1300" b="1">
+                <a:solidFill>
+                  <a:srgbClr val="1B5E20"/>
+                </a:solidFill>
+                <a:latin typeface="Times New Roman"/>
+              </a:rPr>
+              <a:t>Năng lực chất lượng công đoạn:</a:t>
+            </a:r>
+          </a:p>
+          <a:p>
+            <a:pPr>
+              <a:lnSpc>
+                <a:spcPct val="120000"/>
+              </a:lnSpc>
+              <a:spcBef>
+                <a:spcPts val="0"/>
+              </a:spcBef>
+              <a:spcAft>
+                <a:spcPts val="800"/>
+              </a:spcAft>
+            </a:pPr>
+            <a:r>
+              <a:rPr sz="1250" b="0">
+                <a:solidFill>
+                  <a:srgbClr val="1E242B"/>
+                </a:solidFill>
+                <a:latin typeface="Times New Roman"/>
+              </a:rPr>
+              <a:t>Đảm bảo chỉ số năng lực công đoạn đạt Cpk ≥ 1,33 khi đưa vào sản xuất hàng loạt (MP).</a:t>
             </a:r>
           </a:p>
         </p:txBody>

</xml_diff>